<commit_message>
Replace history slides with innovation overview and laser-assisted turning
Co-Authored-By: Claude Opus 5.5 <noreply@anthropic.com>
Claude-Session: https://claude.ai/code/session_01Pq3qwQGSxd4Jb5BwRQrm3f
</commit_message>
<xml_diff>
--- a/Inovace_v_soustruzeni.pptx
+++ b/Inovace_v_soustruzeni.pptx
@@ -116,15 +116,15 @@
   <p:extLst>
     <p:ext uri="{521415D9-36F7-43E2-AB2F-B90AF26B5E84}">
       <p14:sectionLst xmlns:p14="http://schemas.microsoft.com/office/powerpoint/2010/main">
-        <p14:section name="Úvod" id="{e80c3d15-a1a0-e4ce-3e51-52ae206a6940}">
+        <p14:section name="Úvod" id="{3f5fbdc9-b954-4e54-7323-5335daae5a1f}">
           <p14:sldIdLst>
             <p14:sldId id="256"/>
             <p14:sldId id="257"/>
-            <p14:sldId id="258"/>
           </p14:sldIdLst>
         </p14:section>
-        <p14:section name="Inovace" id="{09668408-110e-038d-6937-7364b12a96ae}">
+        <p14:section name="Inovace" id="{b50d186a-d9c5-4e38-c080-3a4efc26a0bb}">
           <p14:sldIdLst>
+            <p14:sldId id="258"/>
             <p14:sldId id="259"/>
             <p14:sldId id="260"/>
             <p14:sldId id="261"/>
@@ -133,7 +133,7 @@
             <p14:sldId id="264"/>
           </p14:sldIdLst>
         </p14:section>
-        <p14:section name="Závěr" id="{e984eee4-085e-1b3b-0726-215617166a8a}">
+        <p14:section name="Závěr" id="{94375f49-d24c-cb6b-6696-a0a82069e8f2}">
           <p14:sldIdLst>
             <p14:sldId id="265"/>
           </p14:sldIdLst>
@@ -542,7 +542,7 @@
           <a:p>
             <a:r>
               <a:rPr lang="en-US" dirty="0"/>
-              <a:t>Dobrý den, dnes vám představím, jak se změnilo soustružení. Většina lidí si pod soustruhem představí stroj, který točí kus kovu a nůž z něj ubírá třísky. To pořád platí, ale dnešní stroje kombinují 3D tisk, tekutý dusík, ultrazvuk, umělou inteligenci a diamantové nástroje. Projdeme stručně historii a pak pět nejzajímavějších inovací.</a:t>
+              <a:t>Dobrý den, dnes vám představím nejzajímavější inovace v soustružení. Většina lidí si pod soustruhem představí stroj, který točí kus kovu a nůž z něj ubírá třísky. Dnešní stroje ale kombinují 3D tisk, tekutý dusík, lasery, ultrazvuk, umělou inteligenci a diamantové nástroje.</a:t>
             </a:r>
             <a:endParaRPr lang="en-US" dirty="0"/>
           </a:p>
@@ -630,7 +630,7 @@
           <a:p>
             <a:r>
               <a:rPr lang="en-US" dirty="0"/>
-              <a:t>Shrnu to: soustružení dnes spojuje 3D tisk s obráběním, místo emulze se chladí tekutým dusíkem, proces hlídají senzory, AI a digitální dvojče, a díky ultrazvuku a diamantovým nástrojům lze obrábět křehké materiály s nanometrovou přesností. Děkuji za pozornost, máte nějaké otázky?</a:t>
+              <a:t>Shrnu to: soustružení dnes spojuje 3D tisk s obráběním, teplo se řídí tekutým dusíkem nebo naopak laserem, proces hlídají senzory, AI a digitální dvojče, a díky ultrazvuku a diamantovým nástrojům lze obrábět křehké materiály s nanometrovou přesností. Děkuji za pozornost, máte nějaké otázky?</a:t>
             </a:r>
             <a:endParaRPr lang="en-US" dirty="0"/>
           </a:p>
@@ -718,7 +718,7 @@
           <a:p>
             <a:r>
               <a:rPr lang="en-US" dirty="0"/>
-              <a:t>Soustruh je jeden z nejstarších strojů vůbec. Už kolem roku 1300 před naším letopočtem používali Egypťané soustruh, kde obrobek roztáčel pomocník pomocí provázku nebo luku. Zlom přišel kolem roku 1800, kdy Henry Maudslay postavil celokovový soustruh, na kterém šlo vyrábět přesné a opakovatelné závity. To byl základ průmyslové revoluce. V roce 1952 představili na MIT první číslicově řízený stroj, předchůdce dnešních CNC. Soustruhu se proto říká matka obráběcích strojů.</a:t>
+              <a:t>Dnes vám představím šest technologií, které v posledních letech mění soustružení. Hybridní stroje spojují 3D tisk kovu s obráběním. Kryogenní obrábění chladí tekutým dusíkem. Laserem asistované soustružení naopak materiál před nožem ohřeje, aby změkl. Chytré nástroje se senzory a umělá inteligence hlídají proces. Ultrazvuk umožňuje obrábět křehké materiály. A diamantové soustružení dosahuje přesnosti v nanometrech. Na konci přidám pár rychlých zajímavostí.</a:t>
             </a:r>
             <a:endParaRPr lang="en-US" dirty="0"/>
           </a:p>
@@ -806,7 +806,7 @@
           <a:p>
             <a:r>
               <a:rPr lang="en-US" dirty="0"/>
-              <a:t>Dnešní soustruh už dávno není jen soustruh. Běžná jsou soustružnicko-frézovací centra, která zvládnou soustružení, frézování i vrtání, takže složitý díl vznikne na jedno upnutí. Díky ose Y a poháněným nástrojům můžeme na soustruhu dělat drážky nebo díry mimo osu. A pro malé přesné součástky se používají dlouhotočné automaty, původem ze švýcarského hodinářství. Dnes na nich vznikají třeba šroubky do zubních implantátů.</a:t>
+              <a:t>První inovací jsou hybridní stroje. Spojují 3D tisk kovu a klasické obrábění v jednom stroji. Laser taví kovový prášek a vrstvu po vrstvě staví hrubý tvar součástky. Této metodě se říká DED, Directed Energy Deposition. Hned potom stejný stroj díl obrobí na přesný rozměr. Výhoda je, že díl se nemusí přepínat ani přenášet, šetří se materiál a dají se i opravovat drahé díly, například opotřebené lopatky turbín: chybějící materiál se navaří a pak obrobí. Takové stroje vyrábí Okuma, DMG MORI nebo Mazak. (Tady se hodí pustit krátké video od výrobce.)</a:t>
             </a:r>
             <a:endParaRPr lang="en-US" dirty="0"/>
           </a:p>
@@ -894,7 +894,7 @@
           <a:p>
             <a:r>
               <a:rPr lang="en-US" dirty="0"/>
-              <a:t>První inovací jsou hybridní stroje. Spojují 3D tisk kovu a klasické obrábění v jednom stroji. Laser taví kovový prášek a vrstvu po vrstvě staví hrubý tvar součástky. Této metodě se říká DED, Directed Energy Deposition. Hned potom stejný stroj díl obrobí na přesný rozměr. Výhoda je, že díl se nemusí přepínat ani přenášet, šetří se materiál a dají se i opravovat drahé díly, například opotřebené lopatky turbín: chybějící materiál se navaří a pak obrobí. Takové stroje vyrábí Okuma, DMG MORI nebo Mazak. (Tady se hodí pustit krátké video od výrobce.)</a:t>
+              <a:t>Při soustružení superslitin, jako je titan nebo Inconel z leteckých motorů, vzniká obrovské teplo, které rychle ničí břit nástroje. Kryogenní obrábění místo klasické emulze z vody a oleje stříká na břit tekutý dusík o teplotě minus 196 stupňů, nebo oxid uhličitý, který se po vystříknutí mění na sníh o teplotě asi minus 78 stupňů. Nástroj pak vydrží déle, běžně o desítky procent, v nejlepších případech i dvakrát až třikrát. Dusík se odpaří a nevzniká žádná toxická odpadní kapalina. Není to ale úplně zadarmo: výroba tekutého dusíku stojí hodně energie a zařízení je drahé.</a:t>
             </a:r>
             <a:endParaRPr lang="en-US" dirty="0"/>
           </a:p>
@@ -982,7 +982,7 @@
           <a:p>
             <a:r>
               <a:rPr lang="en-US" dirty="0"/>
-              <a:t>Při soustružení superslitin, jako je titan nebo Inconel z leteckých motorů, vzniká obrovské teplo, které rychle ničí břit nástroje. Kryogenní obrábění místo klasické emulze z vody a oleje stříká na břit tekutý dusík o teplotě minus 196 stupňů, nebo oxid uhličitý, který se po vystříknutí mění na sníh o teplotě asi minus 78 stupňů. Nástroj pak vydrží déle, běžně o desítky procent, v nejlepších případech i dvakrát až třikrát. Dusík se odpaří a nevzniká žádná toxická odpadní kapalina. Není to ale úplně zadarmo: výroba tekutého dusíku stojí hodně energie a zařízení je drahé.</a:t>
+              <a:t>Třetí technologie jde přesně opačně než kryogenní obrábění. U laserem asistovaného soustružení svítí laser na obrobek těsně před nožem a lokálně ho zahřeje, u technické keramiky i na víc než tisíc stupňů. Ohřátý materiál změkne a nůž ho pak odebírá mnohem snadněji: řezné síly klesnou, nástroj se tolik neopotřebí a křehký materiál nepraská. Používá se hlavně pro keramiku jako nitrid křemíku, pro superslitiny Inconel a titan a pro kalené oceli. Zajímavé je, že kryogenní obrábění chladí nástroj a laser ohřívá obrobek, a obě metody řeší stejný problém: jak obrábět extrémně tvrdé materiály.</a:t>
             </a:r>
             <a:endParaRPr lang="en-US" dirty="0"/>
           </a:p>
@@ -1070,7 +1070,7 @@
           <a:p>
             <a:r>
               <a:rPr lang="en-US" dirty="0"/>
-              <a:t>Třetí oblast je Průmysl 4.0. Do držáků nožů se dnes montují senzory, které při řezu měří vibrace, síly a teplotu. Řídicí systém a umělá inteligence data vyhodnocují: sledují, jak se nástroj opotřebovává, upraví posuv podle zatížení, a když se nástroj zlomí, stroj okamžitě zastaví. Na internetu se často píše, že AI pozná zlom nože zlomek sekundy předem. To je zatím spíš výzkum, v praxi jde hlavně o sledování opotřebení. Třetí věc je digitální dvojče: celý proces se nejdřív nasimuluje v počítači, takže se odhalí kolize dřív, než se stroj vůbec rozjede.</a:t>
+              <a:t>Čtvrtá oblast je Průmysl 4.0. Do držáků nožů se dnes montují senzory, které při řezu měří vibrace, síly a teplotu. Řídicí systém a umělá inteligence data vyhodnocují: sledují, jak se nástroj opotřebovává, upraví posuv podle zatížení, a když se nástroj zlomí, stroj okamžitě zastaví. Na internetu se často píše, že AI pozná zlom nože zlomek sekundy předem. To je zatím spíš výzkum, v praxi jde hlavně o sledování opotřebení. Třetí věc je digitální dvojče: celý proces se nejdřív nasimuluje v počítači, takže se odhalí kolize dřív, než se stroj vůbec rozjede.</a:t>
             </a:r>
             <a:endParaRPr lang="en-US" dirty="0"/>
           </a:p>
@@ -1158,7 +1158,7 @@
           <a:p>
             <a:r>
               <a:rPr lang="en-US" dirty="0"/>
-              <a:t>Čtvrtá inovace je ultrazvukem asistované soustružení. Nůž je napojený na piezoelektrický měnič, který s ním kmitá dvacet až čtyřicet tisíckrát za sekundu, ale jen o pár mikrometrů. Nůž se tak od materiálu neustále nepatrně odtahuje, klesá tření, teplo i řezné síly. Díky tomu lze soustružit i tvrdé a křehké materiály, jako je technická keramika, sklo nebo karbid wolframu, které se jinak obvykle musí brousit. Pomáhá to i u titanu a Inconelu. V průmyslu je to zatím spíš specializovaná technologie.</a:t>
+              <a:t>Pátá inovace je ultrazvukem asistované soustružení. Nůž je napojený na piezoelektrický měnič, který s ním kmitá dvacet až čtyřicet tisíckrát za sekundu, ale jen o pár mikrometrů. Nůž se tak od materiálu neustále nepatrně odtahuje, klesá tření, teplo i řezné síly. Díky tomu lze soustružit i tvrdé a křehké materiály, jako je technická keramika, sklo nebo karbid wolframu, které se jinak obvykle musí brousit. Pomáhá to i u titanu a Inconelu. V průmyslu je to zatím spíš specializovaná technologie.</a:t>
             </a:r>
             <a:endParaRPr lang="en-US" dirty="0"/>
           </a:p>
@@ -1246,7 +1246,7 @@
           <a:p>
             <a:r>
               <a:rPr lang="en-US" dirty="0"/>
-              <a:t>Pátá technologie je diamantové soustružení, anglicky Single Point Diamond Turning. Stroj stojí na obrovském žulovém bloku, vřeteno běží na vzduchových ložiscích a celé je to izolované od vibrací, aby ho nerušila ani projíždějící auta. Nástroj je z jediného krystalu syntetického diamantu. Drsnost povrchu je jen pár nanometrů, tedy asi deset tisíckrát méně, než je tloušťka vlasu. Povrch tak funguje přímo jako zrcadlo, hlavně pro infračervenou optiku. Vyrábí se tak laserová zrcadla, optika do satelitů i kontaktní čočky. Zajímavost: diamantem nejde soustružit ocel, protože uhlík z diamantu se rozpouští v železe a nástroj se zničí.</a:t>
+              <a:t>Šestá technologie je diamantové soustružení, anglicky Single Point Diamond Turning. Stroj stojí na obrovském žulovém bloku, vřeteno běží na vzduchových ložiscích a celé je to izolované od vibrací, aby ho nerušila ani projíždějící auta. Nástroj je z jediného krystalu syntetického diamantu. Drsnost povrchu je jen pár nanometrů, tedy asi deset tisíckrát méně, než je tloušťka vlasu. Povrch tak funguje přímo jako zrcadlo, hlavně pro infračervenou optiku. Vyrábí se tak laserová zrcadla, optika do satelitů i kontaktní čočky. Zajímavost: diamantem nejde soustružit ocel, protože uhlík z diamantu se rozpouští v železe a nástroj se zničí.</a:t>
             </a:r>
             <a:endParaRPr lang="en-US" dirty="0"/>
           </a:p>
@@ -2478,7 +2478,7 @@
                   <a:schemeClr val="bg1"/>
                 </a:solidFill>
               </a:rPr>
-              <a:t>Tekutý dusík místo emulze: delší životnost a čistší provoz</a:t>
+              <a:t>Teplo pod kontrolou: dusík chladí, laser ohřívá</a:t>
             </a:r>
             <a:endParaRPr lang="en-US" sz="1700" dirty="0"/>
           </a:p>
@@ -2880,7 +2880,7 @@
                   <a:schemeClr val="tx1"/>
                 </a:solidFill>
               </a:rPr>
-              <a:t>Od luku k počítači: 3 000 let soustružení</a:t>
+              <a:t>6 technologií, které mění soustružení</a:t>
             </a:r>
             <a:endParaRPr lang="en-US" sz="3400" dirty="0"/>
           </a:p>
@@ -2888,86 +2888,49 @@
       </p:sp>
       <p:sp>
         <p:nvSpPr>
-          <p:cNvPr id="3" name="timeline"/>
+          <p:cNvPr id="3" name="tile 0"/>
           <p:cNvSpPr/>
           <p:nvPr/>
         </p:nvSpPr>
         <p:spPr>
           <a:xfrm>
-            <a:off x="1828800" y="2971800"/>
-            <a:ext cx="8503920" cy="0"/>
-          </a:xfrm>
-          <a:prstGeom prst="line">
-            <a:avLst/>
-          </a:prstGeom>
-          <a:noFill/>
-          <a:ln w="25400">
-            <a:solidFill>
-              <a:schemeClr val="accent3"/>
-            </a:solidFill>
-            <a:prstDash val="solid"/>
-          </a:ln>
-        </p:spPr>
-      </p:sp>
-      <p:sp>
-        <p:nvSpPr>
-          <p:cNvPr id="4" name="year 0"/>
-          <p:cNvSpPr txBox="1"/>
-          <p:nvPr/>
-        </p:nvSpPr>
-        <p:spPr>
-          <a:xfrm>
-            <a:off x="502920" y="1600200"/>
-            <a:ext cx="2651760" cy="457200"/>
-          </a:xfrm>
-          <a:prstGeom prst="rect">
-            <a:avLst/>
-          </a:prstGeom>
-          <a:noFill/>
-          <a:ln/>
-        </p:spPr>
-        <p:txBody>
-          <a:bodyPr wrap="square" lIns="0" tIns="0" rIns="0" bIns="0" rtlCol="0" anchor="t"/>
-          <a:lstStyle/>
-          <a:p>
-            <a:pPr algn="ctr" indent="0" marL="0">
-              <a:buNone/>
-            </a:pPr>
-            <a:r>
-              <a:rPr lang="en-US" sz="2000" b="1" dirty="0">
-                <a:solidFill>
-                  <a:schemeClr val="accent1"/>
-                </a:solidFill>
-              </a:rPr>
-              <a:t>cca 1300 př. n. l.</a:t>
-            </a:r>
-            <a:endParaRPr lang="en-US" sz="2000" dirty="0"/>
-          </a:p>
-        </p:txBody>
-      </p:sp>
-      <p:sp>
-        <p:nvSpPr>
-          <p:cNvPr id="5" name="timeline icon 0 circle"/>
+            <a:off x="548640" y="1508760"/>
+            <a:ext cx="3520440" cy="2057400"/>
+          </a:xfrm>
+          <a:prstGeom prst="roundRect">
+            <a:avLst>
+              <a:gd name="adj" fmla="val 5333"/>
+            </a:avLst>
+          </a:prstGeom>
+          <a:solidFill>
+            <a:schemeClr val="bg2"/>
+          </a:solidFill>
+          <a:ln/>
+        </p:spPr>
+      </p:sp>
+      <p:sp>
+        <p:nvSpPr>
+          <p:cNvPr id="4" name="tile icon 0 circle"/>
           <p:cNvSpPr/>
           <p:nvPr/>
         </p:nvSpPr>
         <p:spPr>
           <a:xfrm>
-            <a:off x="1371600" y="2514600"/>
-            <a:ext cx="914400" cy="914400"/>
+            <a:off x="822960" y="1783080"/>
+            <a:ext cx="731520" cy="731520"/>
           </a:xfrm>
           <a:prstGeom prst="ellipse">
             <a:avLst/>
           </a:prstGeom>
           <a:solidFill>
-            <a:schemeClr val="tx2"/>
+            <a:schemeClr val="accent1"/>
           </a:solidFill>
           <a:ln/>
         </p:spPr>
       </p:sp>
       <p:pic>
         <p:nvPicPr>
-          <p:cNvPr id="6" name="timeline icon 0" descr="timeline icon 0">    </p:cNvPr>
+          <p:cNvPr id="5" name="tile icon 0" descr="tile icon 0">    </p:cNvPr>
           <p:cNvPicPr>
             <a:picLocks noChangeAspect="1"/>
           </p:cNvPicPr>
@@ -2981,8 +2944,8 @@
         </p:blipFill>
         <p:spPr>
           <a:xfrm>
-            <a:off x="1572768" y="2715768"/>
-            <a:ext cx="512064" cy="512064"/>
+            <a:off x="983894" y="1944014"/>
+            <a:ext cx="409651" cy="409651"/>
           </a:xfrm>
           <a:prstGeom prst="rect">
             <a:avLst/>
@@ -2991,14 +2954,61 @@
       </p:pic>
       <p:sp>
         <p:nvSpPr>
-          <p:cNvPr id="7" name="desc 0"/>
-          <p:cNvSpPr txBox="1"/>
-          <p:nvPr/>
-        </p:nvSpPr>
-        <p:spPr>
-          <a:xfrm>
-            <a:off x="502920" y="3611880"/>
-            <a:ext cx="2651760" cy="1097280"/>
+          <p:cNvPr id="6" name="tile title 0"/>
+          <p:cNvSpPr txBox="1"/>
+          <p:nvPr/>
+        </p:nvSpPr>
+        <p:spPr>
+          <a:xfrm>
+            <a:off x="1737360" y="1783080"/>
+            <a:ext cx="2194560" cy="731520"/>
+          </a:xfrm>
+          <a:prstGeom prst="rect">
+            <a:avLst/>
+          </a:prstGeom>
+          <a:noFill/>
+          <a:ln/>
+        </p:spPr>
+        <p:txBody>
+          <a:bodyPr wrap="square" lIns="0" tIns="0" rIns="0" bIns="0" rtlCol="0" anchor="ctr"/>
+          <a:lstStyle/>
+          <a:p>
+            <a:pPr indent="0" marL="0">
+              <a:buNone/>
+            </a:pPr>
+            <a:r>
+              <a:rPr lang="en-US" sz="1600" b="1" dirty="0">
+                <a:solidFill>
+                  <a:schemeClr val="accent1"/>
+                </a:solidFill>
+              </a:rPr>
+              <a:t>1  </a:t>
+            </a:r>
+            <a:pPr indent="0" marL="0">
+              <a:buNone/>
+            </a:pPr>
+            <a:r>
+              <a:rPr lang="en-US" sz="1600" b="1" dirty="0">
+                <a:solidFill>
+                  <a:schemeClr val="tx1"/>
+                </a:solidFill>
+              </a:rPr>
+              <a:t>Hybridní stroje</a:t>
+            </a:r>
+            <a:endParaRPr lang="en-US" sz="1600" dirty="0"/>
+          </a:p>
+        </p:txBody>
+      </p:sp>
+      <p:sp>
+        <p:nvSpPr>
+          <p:cNvPr id="7" name="tile body 0"/>
+          <p:cNvSpPr txBox="1"/>
+          <p:nvPr/>
+        </p:nvSpPr>
+        <p:spPr>
+          <a:xfrm>
+            <a:off x="822960" y="2697480"/>
+            <a:ext cx="2971800" cy="731520"/>
           </a:xfrm>
           <a:prstGeom prst="rect">
             <a:avLst/>
@@ -3010,7 +3020,7 @@
           <a:bodyPr wrap="square" lIns="0" tIns="0" rIns="0" bIns="0" rtlCol="0" anchor="t"/>
           <a:lstStyle/>
           <a:p>
-            <a:pPr algn="ctr" indent="0" marL="0">
+            <a:pPr indent="0" marL="0">
               <a:buNone/>
             </a:pPr>
             <a:r>
@@ -3019,7 +3029,7 @@
                   <a:schemeClr val="tx2"/>
                 </a:solidFill>
               </a:rPr>
-              <a:t>Egypt: obrobek roztáčí pomocník provázkem nebo lukem</a:t>
+              <a:t>3D tisk kovu a obrábění v jednom stroji</a:t>
             </a:r>
             <a:endParaRPr lang="en-US" sz="1500" dirty="0"/>
           </a:p>
@@ -3027,63 +3037,49 @@
       </p:sp>
       <p:sp>
         <p:nvSpPr>
-          <p:cNvPr id="8" name="year 1"/>
-          <p:cNvSpPr txBox="1"/>
-          <p:nvPr/>
-        </p:nvSpPr>
-        <p:spPr>
-          <a:xfrm>
-            <a:off x="3337560" y="1600200"/>
-            <a:ext cx="2651760" cy="457200"/>
-          </a:xfrm>
-          <a:prstGeom prst="rect">
-            <a:avLst/>
-          </a:prstGeom>
-          <a:noFill/>
-          <a:ln/>
-        </p:spPr>
-        <p:txBody>
-          <a:bodyPr wrap="square" lIns="0" tIns="0" rIns="0" bIns="0" rtlCol="0" anchor="t"/>
-          <a:lstStyle/>
-          <a:p>
-            <a:pPr algn="ctr" indent="0" marL="0">
-              <a:buNone/>
-            </a:pPr>
-            <a:r>
-              <a:rPr lang="en-US" sz="2000" b="1" dirty="0">
-                <a:solidFill>
-                  <a:schemeClr val="accent1"/>
-                </a:solidFill>
-              </a:rPr>
-              <a:t>cca 1800</a:t>
-            </a:r>
-            <a:endParaRPr lang="en-US" sz="2000" dirty="0"/>
-          </a:p>
-        </p:txBody>
-      </p:sp>
-      <p:sp>
-        <p:nvSpPr>
-          <p:cNvPr id="9" name="timeline icon 1 circle"/>
+          <p:cNvPr id="8" name="tile 1"/>
           <p:cNvSpPr/>
           <p:nvPr/>
         </p:nvSpPr>
         <p:spPr>
           <a:xfrm>
-            <a:off x="4206240" y="2514600"/>
-            <a:ext cx="914400" cy="914400"/>
+            <a:off x="4320540" y="1508760"/>
+            <a:ext cx="3520440" cy="2057400"/>
+          </a:xfrm>
+          <a:prstGeom prst="roundRect">
+            <a:avLst>
+              <a:gd name="adj" fmla="val 5333"/>
+            </a:avLst>
+          </a:prstGeom>
+          <a:solidFill>
+            <a:schemeClr val="bg2"/>
+          </a:solidFill>
+          <a:ln/>
+        </p:spPr>
+      </p:sp>
+      <p:sp>
+        <p:nvSpPr>
+          <p:cNvPr id="9" name="tile icon 1 circle"/>
+          <p:cNvSpPr/>
+          <p:nvPr/>
+        </p:nvSpPr>
+        <p:spPr>
+          <a:xfrm>
+            <a:off x="4594860" y="1783080"/>
+            <a:ext cx="731520" cy="731520"/>
           </a:xfrm>
           <a:prstGeom prst="ellipse">
             <a:avLst/>
           </a:prstGeom>
           <a:solidFill>
-            <a:schemeClr val="tx2"/>
+            <a:schemeClr val="accent1"/>
           </a:solidFill>
           <a:ln/>
         </p:spPr>
       </p:sp>
       <p:pic>
         <p:nvPicPr>
-          <p:cNvPr id="10" name="timeline icon 1" descr="timeline icon 1">    </p:cNvPr>
+          <p:cNvPr id="10" name="tile icon 1" descr="tile icon 1">    </p:cNvPr>
           <p:cNvPicPr>
             <a:picLocks noChangeAspect="1"/>
           </p:cNvPicPr>
@@ -3097,8 +3093,8 @@
         </p:blipFill>
         <p:spPr>
           <a:xfrm>
-            <a:off x="4407408" y="2715768"/>
-            <a:ext cx="512064" cy="512064"/>
+            <a:off x="4755794" y="1944014"/>
+            <a:ext cx="409651" cy="409651"/>
           </a:xfrm>
           <a:prstGeom prst="rect">
             <a:avLst/>
@@ -3107,14 +3103,61 @@
       </p:pic>
       <p:sp>
         <p:nvSpPr>
-          <p:cNvPr id="11" name="desc 1"/>
-          <p:cNvSpPr txBox="1"/>
-          <p:nvPr/>
-        </p:nvSpPr>
-        <p:spPr>
-          <a:xfrm>
-            <a:off x="3337560" y="3611880"/>
-            <a:ext cx="2651760" cy="1097280"/>
+          <p:cNvPr id="11" name="tile title 1"/>
+          <p:cNvSpPr txBox="1"/>
+          <p:nvPr/>
+        </p:nvSpPr>
+        <p:spPr>
+          <a:xfrm>
+            <a:off x="5509260" y="1783080"/>
+            <a:ext cx="2194560" cy="731520"/>
+          </a:xfrm>
+          <a:prstGeom prst="rect">
+            <a:avLst/>
+          </a:prstGeom>
+          <a:noFill/>
+          <a:ln/>
+        </p:spPr>
+        <p:txBody>
+          <a:bodyPr wrap="square" lIns="0" tIns="0" rIns="0" bIns="0" rtlCol="0" anchor="ctr"/>
+          <a:lstStyle/>
+          <a:p>
+            <a:pPr indent="0" marL="0">
+              <a:buNone/>
+            </a:pPr>
+            <a:r>
+              <a:rPr lang="en-US" sz="1600" b="1" dirty="0">
+                <a:solidFill>
+                  <a:schemeClr val="accent1"/>
+                </a:solidFill>
+              </a:rPr>
+              <a:t>2  </a:t>
+            </a:r>
+            <a:pPr indent="0" marL="0">
+              <a:buNone/>
+            </a:pPr>
+            <a:r>
+              <a:rPr lang="en-US" sz="1600" b="1" dirty="0">
+                <a:solidFill>
+                  <a:schemeClr val="tx1"/>
+                </a:solidFill>
+              </a:rPr>
+              <a:t>Kryogenní obrábění</a:t>
+            </a:r>
+            <a:endParaRPr lang="en-US" sz="1600" dirty="0"/>
+          </a:p>
+        </p:txBody>
+      </p:sp>
+      <p:sp>
+        <p:nvSpPr>
+          <p:cNvPr id="12" name="tile body 1"/>
+          <p:cNvSpPr txBox="1"/>
+          <p:nvPr/>
+        </p:nvSpPr>
+        <p:spPr>
+          <a:xfrm>
+            <a:off x="4594860" y="2697480"/>
+            <a:ext cx="2971800" cy="731520"/>
           </a:xfrm>
           <a:prstGeom prst="rect">
             <a:avLst/>
@@ -3126,7 +3169,7 @@
           <a:bodyPr wrap="square" lIns="0" tIns="0" rIns="0" bIns="0" rtlCol="0" anchor="t"/>
           <a:lstStyle/>
           <a:p>
-            <a:pPr algn="ctr" indent="0" marL="0">
+            <a:pPr indent="0" marL="0">
               <a:buNone/>
             </a:pPr>
             <a:r>
@@ -3135,7 +3178,7 @@
                   <a:schemeClr val="tx2"/>
                 </a:solidFill>
               </a:rPr>
-              <a:t>Henry Maudslay: celokovový soustruh na přesné závity</a:t>
+              <a:t>Chlazení tekutým dusíkem místo emulze</a:t>
             </a:r>
             <a:endParaRPr lang="en-US" sz="1500" dirty="0"/>
           </a:p>
@@ -3143,63 +3186,49 @@
       </p:sp>
       <p:sp>
         <p:nvSpPr>
-          <p:cNvPr id="12" name="year 2"/>
-          <p:cNvSpPr txBox="1"/>
-          <p:nvPr/>
-        </p:nvSpPr>
-        <p:spPr>
-          <a:xfrm>
-            <a:off x="6172200" y="1600200"/>
-            <a:ext cx="2651760" cy="457200"/>
-          </a:xfrm>
-          <a:prstGeom prst="rect">
-            <a:avLst/>
-          </a:prstGeom>
-          <a:noFill/>
-          <a:ln/>
-        </p:spPr>
-        <p:txBody>
-          <a:bodyPr wrap="square" lIns="0" tIns="0" rIns="0" bIns="0" rtlCol="0" anchor="t"/>
-          <a:lstStyle/>
-          <a:p>
-            <a:pPr algn="ctr" indent="0" marL="0">
-              <a:buNone/>
-            </a:pPr>
-            <a:r>
-              <a:rPr lang="en-US" sz="2000" b="1" dirty="0">
-                <a:solidFill>
-                  <a:schemeClr val="accent1"/>
-                </a:solidFill>
-              </a:rPr>
-              <a:t>1952</a:t>
-            </a:r>
-            <a:endParaRPr lang="en-US" sz="2000" dirty="0"/>
-          </a:p>
-        </p:txBody>
-      </p:sp>
-      <p:sp>
-        <p:nvSpPr>
-          <p:cNvPr id="13" name="timeline icon 2 circle"/>
+          <p:cNvPr id="13" name="tile 2"/>
           <p:cNvSpPr/>
           <p:nvPr/>
         </p:nvSpPr>
         <p:spPr>
           <a:xfrm>
-            <a:off x="7040880" y="2514600"/>
-            <a:ext cx="914400" cy="914400"/>
+            <a:off x="8092440" y="1508760"/>
+            <a:ext cx="3520440" cy="2057400"/>
+          </a:xfrm>
+          <a:prstGeom prst="roundRect">
+            <a:avLst>
+              <a:gd name="adj" fmla="val 5333"/>
+            </a:avLst>
+          </a:prstGeom>
+          <a:solidFill>
+            <a:schemeClr val="bg2"/>
+          </a:solidFill>
+          <a:ln/>
+        </p:spPr>
+      </p:sp>
+      <p:sp>
+        <p:nvSpPr>
+          <p:cNvPr id="14" name="tile icon 2 circle"/>
+          <p:cNvSpPr/>
+          <p:nvPr/>
+        </p:nvSpPr>
+        <p:spPr>
+          <a:xfrm>
+            <a:off x="8366760" y="1783080"/>
+            <a:ext cx="731520" cy="731520"/>
           </a:xfrm>
           <a:prstGeom prst="ellipse">
             <a:avLst/>
           </a:prstGeom>
           <a:solidFill>
-            <a:schemeClr val="tx2"/>
+            <a:schemeClr val="accent1"/>
           </a:solidFill>
           <a:ln/>
         </p:spPr>
       </p:sp>
       <p:pic>
         <p:nvPicPr>
-          <p:cNvPr id="14" name="timeline icon 2" descr="timeline icon 2">    </p:cNvPr>
+          <p:cNvPr id="15" name="tile icon 2" descr="tile icon 2">    </p:cNvPr>
           <p:cNvPicPr>
             <a:picLocks noChangeAspect="1"/>
           </p:cNvPicPr>
@@ -3213,8 +3242,8 @@
         </p:blipFill>
         <p:spPr>
           <a:xfrm>
-            <a:off x="7242048" y="2715768"/>
-            <a:ext cx="512064" cy="512064"/>
+            <a:off x="8527694" y="1944014"/>
+            <a:ext cx="409651" cy="409651"/>
           </a:xfrm>
           <a:prstGeom prst="rect">
             <a:avLst/>
@@ -3223,14 +3252,61 @@
       </p:pic>
       <p:sp>
         <p:nvSpPr>
-          <p:cNvPr id="15" name="desc 2"/>
-          <p:cNvSpPr txBox="1"/>
-          <p:nvPr/>
-        </p:nvSpPr>
-        <p:spPr>
-          <a:xfrm>
-            <a:off x="6172200" y="3611880"/>
-            <a:ext cx="2651760" cy="1097280"/>
+          <p:cNvPr id="16" name="tile title 2"/>
+          <p:cNvSpPr txBox="1"/>
+          <p:nvPr/>
+        </p:nvSpPr>
+        <p:spPr>
+          <a:xfrm>
+            <a:off x="9281160" y="1783080"/>
+            <a:ext cx="2194560" cy="731520"/>
+          </a:xfrm>
+          <a:prstGeom prst="rect">
+            <a:avLst/>
+          </a:prstGeom>
+          <a:noFill/>
+          <a:ln/>
+        </p:spPr>
+        <p:txBody>
+          <a:bodyPr wrap="square" lIns="0" tIns="0" rIns="0" bIns="0" rtlCol="0" anchor="ctr"/>
+          <a:lstStyle/>
+          <a:p>
+            <a:pPr indent="0" marL="0">
+              <a:buNone/>
+            </a:pPr>
+            <a:r>
+              <a:rPr lang="en-US" sz="1600" b="1" dirty="0">
+                <a:solidFill>
+                  <a:schemeClr val="accent1"/>
+                </a:solidFill>
+              </a:rPr>
+              <a:t>3  </a:t>
+            </a:r>
+            <a:pPr indent="0" marL="0">
+              <a:buNone/>
+            </a:pPr>
+            <a:r>
+              <a:rPr lang="en-US" sz="1600" b="1" dirty="0">
+                <a:solidFill>
+                  <a:schemeClr val="tx1"/>
+                </a:solidFill>
+              </a:rPr>
+              <a:t>Laserový ohřev</a:t>
+            </a:r>
+            <a:endParaRPr lang="en-US" sz="1600" dirty="0"/>
+          </a:p>
+        </p:txBody>
+      </p:sp>
+      <p:sp>
+        <p:nvSpPr>
+          <p:cNvPr id="17" name="tile body 2"/>
+          <p:cNvSpPr txBox="1"/>
+          <p:nvPr/>
+        </p:nvSpPr>
+        <p:spPr>
+          <a:xfrm>
+            <a:off x="8366760" y="2697480"/>
+            <a:ext cx="2971800" cy="731520"/>
           </a:xfrm>
           <a:prstGeom prst="rect">
             <a:avLst/>
@@ -3242,7 +3318,7 @@
           <a:bodyPr wrap="square" lIns="0" tIns="0" rIns="0" bIns="0" rtlCol="0" anchor="t"/>
           <a:lstStyle/>
           <a:p>
-            <a:pPr algn="ctr" indent="0" marL="0">
+            <a:pPr indent="0" marL="0">
               <a:buNone/>
             </a:pPr>
             <a:r>
@@ -3251,7 +3327,7 @@
                   <a:schemeClr val="tx2"/>
                 </a:solidFill>
               </a:rPr>
-              <a:t>MIT: první číslicově řízený (NC) obráběcí stroj</a:t>
+              <a:t>Laser změkčí materiál těsně před nožem</a:t>
             </a:r>
             <a:endParaRPr lang="en-US" sz="1500" dirty="0"/>
           </a:p>
@@ -3259,50 +3335,36 @@
       </p:sp>
       <p:sp>
         <p:nvSpPr>
-          <p:cNvPr id="16" name="year 3"/>
-          <p:cNvSpPr txBox="1"/>
-          <p:nvPr/>
-        </p:nvSpPr>
-        <p:spPr>
-          <a:xfrm>
-            <a:off x="9006840" y="1600200"/>
-            <a:ext cx="2651760" cy="457200"/>
-          </a:xfrm>
-          <a:prstGeom prst="rect">
-            <a:avLst/>
-          </a:prstGeom>
-          <a:noFill/>
-          <a:ln/>
-        </p:spPr>
-        <p:txBody>
-          <a:bodyPr wrap="square" lIns="0" tIns="0" rIns="0" bIns="0" rtlCol="0" anchor="t"/>
-          <a:lstStyle/>
-          <a:p>
-            <a:pPr algn="ctr" indent="0" marL="0">
-              <a:buNone/>
-            </a:pPr>
-            <a:r>
-              <a:rPr lang="en-US" sz="2000" b="1" dirty="0">
-                <a:solidFill>
-                  <a:schemeClr val="accent1"/>
-                </a:solidFill>
-              </a:rPr>
-              <a:t>Dnes</a:t>
-            </a:r>
-            <a:endParaRPr lang="en-US" sz="2000" dirty="0"/>
-          </a:p>
-        </p:txBody>
-      </p:sp>
-      <p:sp>
-        <p:nvSpPr>
-          <p:cNvPr id="17" name="timeline icon 3 circle"/>
+          <p:cNvPr id="18" name="tile 3"/>
           <p:cNvSpPr/>
           <p:nvPr/>
         </p:nvSpPr>
         <p:spPr>
           <a:xfrm>
-            <a:off x="9875520" y="2514600"/>
-            <a:ext cx="914400" cy="914400"/>
+            <a:off x="548640" y="3840480"/>
+            <a:ext cx="3520440" cy="2057400"/>
+          </a:xfrm>
+          <a:prstGeom prst="roundRect">
+            <a:avLst>
+              <a:gd name="adj" fmla="val 5333"/>
+            </a:avLst>
+          </a:prstGeom>
+          <a:solidFill>
+            <a:schemeClr val="bg2"/>
+          </a:solidFill>
+          <a:ln/>
+        </p:spPr>
+      </p:sp>
+      <p:sp>
+        <p:nvSpPr>
+          <p:cNvPr id="19" name="tile icon 3 circle"/>
+          <p:cNvSpPr/>
+          <p:nvPr/>
+        </p:nvSpPr>
+        <p:spPr>
+          <a:xfrm>
+            <a:off x="822960" y="4114800"/>
+            <a:ext cx="731520" cy="731520"/>
           </a:xfrm>
           <a:prstGeom prst="ellipse">
             <a:avLst/>
@@ -3315,7 +3377,7 @@
       </p:sp>
       <p:pic>
         <p:nvPicPr>
-          <p:cNvPr id="18" name="timeline icon 3" descr="timeline icon 3">    </p:cNvPr>
+          <p:cNvPr id="20" name="tile icon 3" descr="tile icon 3">    </p:cNvPr>
           <p:cNvPicPr>
             <a:picLocks noChangeAspect="1"/>
           </p:cNvPicPr>
@@ -3329,8 +3391,8 @@
         </p:blipFill>
         <p:spPr>
           <a:xfrm>
-            <a:off x="10076688" y="2715768"/>
-            <a:ext cx="512064" cy="512064"/>
+            <a:off x="983894" y="4275734"/>
+            <a:ext cx="409651" cy="409651"/>
           </a:xfrm>
           <a:prstGeom prst="rect">
             <a:avLst/>
@@ -3339,14 +3401,61 @@
       </p:pic>
       <p:sp>
         <p:nvSpPr>
-          <p:cNvPr id="19" name="desc 3"/>
-          <p:cNvSpPr txBox="1"/>
-          <p:nvPr/>
-        </p:nvSpPr>
-        <p:spPr>
-          <a:xfrm>
-            <a:off x="9006840" y="3611880"/>
-            <a:ext cx="2651760" cy="1097280"/>
+          <p:cNvPr id="21" name="tile title 3"/>
+          <p:cNvSpPr txBox="1"/>
+          <p:nvPr/>
+        </p:nvSpPr>
+        <p:spPr>
+          <a:xfrm>
+            <a:off x="1737360" y="4114800"/>
+            <a:ext cx="2194560" cy="731520"/>
+          </a:xfrm>
+          <a:prstGeom prst="rect">
+            <a:avLst/>
+          </a:prstGeom>
+          <a:noFill/>
+          <a:ln/>
+        </p:spPr>
+        <p:txBody>
+          <a:bodyPr wrap="square" lIns="0" tIns="0" rIns="0" bIns="0" rtlCol="0" anchor="ctr"/>
+          <a:lstStyle/>
+          <a:p>
+            <a:pPr indent="0" marL="0">
+              <a:buNone/>
+            </a:pPr>
+            <a:r>
+              <a:rPr lang="en-US" sz="1600" b="1" dirty="0">
+                <a:solidFill>
+                  <a:schemeClr val="accent1"/>
+                </a:solidFill>
+              </a:rPr>
+              <a:t>4  </a:t>
+            </a:r>
+            <a:pPr indent="0" marL="0">
+              <a:buNone/>
+            </a:pPr>
+            <a:r>
+              <a:rPr lang="en-US" sz="1600" b="1" dirty="0">
+                <a:solidFill>
+                  <a:schemeClr val="tx1"/>
+                </a:solidFill>
+              </a:rPr>
+              <a:t>Chytré nástroje a AI</a:t>
+            </a:r>
+            <a:endParaRPr lang="en-US" sz="1600" dirty="0"/>
+          </a:p>
+        </p:txBody>
+      </p:sp>
+      <p:sp>
+        <p:nvSpPr>
+          <p:cNvPr id="22" name="tile body 3"/>
+          <p:cNvSpPr txBox="1"/>
+          <p:nvPr/>
+        </p:nvSpPr>
+        <p:spPr>
+          <a:xfrm>
+            <a:off x="822960" y="5029200"/>
+            <a:ext cx="2971800" cy="731520"/>
           </a:xfrm>
           <a:prstGeom prst="rect">
             <a:avLst/>
@@ -3358,7 +3467,7 @@
           <a:bodyPr wrap="square" lIns="0" tIns="0" rIns="0" bIns="0" rtlCol="0" anchor="t"/>
           <a:lstStyle/>
           <a:p>
-            <a:pPr algn="ctr" indent="0" marL="0">
+            <a:pPr indent="0" marL="0">
               <a:buNone/>
             </a:pPr>
             <a:r>
@@ -3367,7 +3476,7 @@
                   <a:schemeClr val="tx2"/>
                 </a:solidFill>
               </a:rPr>
-              <a:t>CNC centra se senzory, simulací a prvky AI</a:t>
+              <a:t>Senzory, adaptivní řízení, digitální dvojče</a:t>
             </a:r>
             <a:endParaRPr lang="en-US" sz="1500" dirty="0"/>
           </a:p>
@@ -3375,18 +3484,18 @@
       </p:sp>
       <p:sp>
         <p:nvSpPr>
-          <p:cNvPr id="20" name="quote card"/>
+          <p:cNvPr id="23" name="tile 4"/>
           <p:cNvSpPr/>
           <p:nvPr/>
         </p:nvSpPr>
         <p:spPr>
           <a:xfrm>
-            <a:off x="548640" y="5074920"/>
-            <a:ext cx="11064240" cy="960120"/>
+            <a:off x="4320540" y="3840480"/>
+            <a:ext cx="3520440" cy="2057400"/>
           </a:xfrm>
           <a:prstGeom prst="roundRect">
             <a:avLst>
-              <a:gd name="adj" fmla="val 11429"/>
+              <a:gd name="adj" fmla="val 5333"/>
             </a:avLst>
           </a:prstGeom>
           <a:solidFill>
@@ -3397,14 +3506,58 @@
       </p:sp>
       <p:sp>
         <p:nvSpPr>
-          <p:cNvPr id="21" name="quote"/>
-          <p:cNvSpPr txBox="1"/>
-          <p:nvPr/>
-        </p:nvSpPr>
-        <p:spPr>
-          <a:xfrm>
-            <a:off x="822960" y="5074920"/>
-            <a:ext cx="10515600" cy="960120"/>
+          <p:cNvPr id="24" name="tile icon 4 circle"/>
+          <p:cNvSpPr/>
+          <p:nvPr/>
+        </p:nvSpPr>
+        <p:spPr>
+          <a:xfrm>
+            <a:off x="4594860" y="4114800"/>
+            <a:ext cx="731520" cy="731520"/>
+          </a:xfrm>
+          <a:prstGeom prst="ellipse">
+            <a:avLst/>
+          </a:prstGeom>
+          <a:solidFill>
+            <a:schemeClr val="accent1"/>
+          </a:solidFill>
+          <a:ln/>
+        </p:spPr>
+      </p:sp>
+      <p:pic>
+        <p:nvPicPr>
+          <p:cNvPr id="25" name="tile icon 4" descr="tile icon 4">    </p:cNvPr>
+          <p:cNvPicPr>
+            <a:picLocks noChangeAspect="1"/>
+          </p:cNvPicPr>
+          <p:nvPr/>
+        </p:nvPicPr>
+        <p:blipFill>
+          <a:blip r:embed="rId5"/>
+          <a:stretch>
+            <a:fillRect/>
+          </a:stretch>
+        </p:blipFill>
+        <p:spPr>
+          <a:xfrm>
+            <a:off x="4755794" y="4275734"/>
+            <a:ext cx="409651" cy="409651"/>
+          </a:xfrm>
+          <a:prstGeom prst="rect">
+            <a:avLst/>
+          </a:prstGeom>
+        </p:spPr>
+      </p:pic>
+      <p:sp>
+        <p:nvSpPr>
+          <p:cNvPr id="26" name="tile title 4"/>
+          <p:cNvSpPr txBox="1"/>
+          <p:nvPr/>
+        </p:nvSpPr>
+        <p:spPr>
+          <a:xfrm>
+            <a:off x="5509260" y="4114800"/>
+            <a:ext cx="2194560" cy="731520"/>
           </a:xfrm>
           <a:prstGeom prst="rect">
             <a:avLst/>
@@ -3422,23 +3575,208 @@
             <a:r>
               <a:rPr lang="en-US" sz="1600" b="1" dirty="0">
                 <a:solidFill>
+                  <a:schemeClr val="accent1"/>
+                </a:solidFill>
+              </a:rPr>
+              <a:t>5  </a:t>
+            </a:r>
+            <a:pPr indent="0" marL="0">
+              <a:buNone/>
+            </a:pPr>
+            <a:r>
+              <a:rPr lang="en-US" sz="1600" b="1" dirty="0">
+                <a:solidFill>
                   <a:schemeClr val="tx1"/>
                 </a:solidFill>
               </a:rPr>
-              <a:t>„Matka obráběcích strojů“ </a:t>
-            </a:r>
+              <a:t>Ultrazvuk</a:t>
+            </a:r>
+            <a:endParaRPr lang="en-US" sz="1600" dirty="0"/>
+          </a:p>
+        </p:txBody>
+      </p:sp>
+      <p:sp>
+        <p:nvSpPr>
+          <p:cNvPr id="27" name="tile body 4"/>
+          <p:cNvSpPr txBox="1"/>
+          <p:nvPr/>
+        </p:nvSpPr>
+        <p:spPr>
+          <a:xfrm>
+            <a:off x="4594860" y="5029200"/>
+            <a:ext cx="2971800" cy="731520"/>
+          </a:xfrm>
+          <a:prstGeom prst="rect">
+            <a:avLst/>
+          </a:prstGeom>
+          <a:noFill/>
+          <a:ln/>
+        </p:spPr>
+        <p:txBody>
+          <a:bodyPr wrap="square" lIns="0" tIns="0" rIns="0" bIns="0" rtlCol="0" anchor="t"/>
+          <a:lstStyle/>
+          <a:p>
             <a:pPr indent="0" marL="0">
               <a:buNone/>
             </a:pPr>
             <a:r>
-              <a:rPr lang="en-US" sz="1600" dirty="0">
+              <a:rPr lang="en-US" sz="1500" dirty="0">
                 <a:solidFill>
                   <a:schemeClr val="tx2"/>
                 </a:solidFill>
               </a:rPr>
-              <a:t>– bez přesného soustruhu by nešly vyrobit šrouby, hřídele, ložiska ani další stroje.</a:t>
+              <a:t>Kmitající nůž obrobí i keramiku a sklo</a:t>
+            </a:r>
+            <a:endParaRPr lang="en-US" sz="1500" dirty="0"/>
+          </a:p>
+        </p:txBody>
+      </p:sp>
+      <p:sp>
+        <p:nvSpPr>
+          <p:cNvPr id="28" name="tile 5"/>
+          <p:cNvSpPr/>
+          <p:nvPr/>
+        </p:nvSpPr>
+        <p:spPr>
+          <a:xfrm>
+            <a:off x="8092440" y="3840480"/>
+            <a:ext cx="3520440" cy="2057400"/>
+          </a:xfrm>
+          <a:prstGeom prst="roundRect">
+            <a:avLst>
+              <a:gd name="adj" fmla="val 5333"/>
+            </a:avLst>
+          </a:prstGeom>
+          <a:solidFill>
+            <a:schemeClr val="bg2"/>
+          </a:solidFill>
+          <a:ln/>
+        </p:spPr>
+      </p:sp>
+      <p:sp>
+        <p:nvSpPr>
+          <p:cNvPr id="29" name="tile icon 5 circle"/>
+          <p:cNvSpPr/>
+          <p:nvPr/>
+        </p:nvSpPr>
+        <p:spPr>
+          <a:xfrm>
+            <a:off x="8366760" y="4114800"/>
+            <a:ext cx="731520" cy="731520"/>
+          </a:xfrm>
+          <a:prstGeom prst="ellipse">
+            <a:avLst/>
+          </a:prstGeom>
+          <a:solidFill>
+            <a:schemeClr val="accent1"/>
+          </a:solidFill>
+          <a:ln/>
+        </p:spPr>
+      </p:sp>
+      <p:pic>
+        <p:nvPicPr>
+          <p:cNvPr id="30" name="tile icon 5" descr="tile icon 5">    </p:cNvPr>
+          <p:cNvPicPr>
+            <a:picLocks noChangeAspect="1"/>
+          </p:cNvPicPr>
+          <p:nvPr/>
+        </p:nvPicPr>
+        <p:blipFill>
+          <a:blip r:embed="rId6"/>
+          <a:stretch>
+            <a:fillRect/>
+          </a:stretch>
+        </p:blipFill>
+        <p:spPr>
+          <a:xfrm>
+            <a:off x="8527694" y="4275734"/>
+            <a:ext cx="409651" cy="409651"/>
+          </a:xfrm>
+          <a:prstGeom prst="rect">
+            <a:avLst/>
+          </a:prstGeom>
+        </p:spPr>
+      </p:pic>
+      <p:sp>
+        <p:nvSpPr>
+          <p:cNvPr id="31" name="tile title 5"/>
+          <p:cNvSpPr txBox="1"/>
+          <p:nvPr/>
+        </p:nvSpPr>
+        <p:spPr>
+          <a:xfrm>
+            <a:off x="9281160" y="4114800"/>
+            <a:ext cx="2194560" cy="731520"/>
+          </a:xfrm>
+          <a:prstGeom prst="rect">
+            <a:avLst/>
+          </a:prstGeom>
+          <a:noFill/>
+          <a:ln/>
+        </p:spPr>
+        <p:txBody>
+          <a:bodyPr wrap="square" lIns="0" tIns="0" rIns="0" bIns="0" rtlCol="0" anchor="ctr"/>
+          <a:lstStyle/>
+          <a:p>
+            <a:pPr indent="0" marL="0">
+              <a:buNone/>
+            </a:pPr>
+            <a:r>
+              <a:rPr lang="en-US" sz="1600" b="1" dirty="0">
+                <a:solidFill>
+                  <a:schemeClr val="accent1"/>
+                </a:solidFill>
+              </a:rPr>
+              <a:t>6  </a:t>
+            </a:r>
+            <a:pPr indent="0" marL="0">
+              <a:buNone/>
+            </a:pPr>
+            <a:r>
+              <a:rPr lang="en-US" sz="1600" b="1" dirty="0">
+                <a:solidFill>
+                  <a:schemeClr val="tx1"/>
+                </a:solidFill>
+              </a:rPr>
+              <a:t>Diamantové soustružení</a:t>
             </a:r>
             <a:endParaRPr lang="en-US" sz="1600" dirty="0"/>
+          </a:p>
+        </p:txBody>
+      </p:sp>
+      <p:sp>
+        <p:nvSpPr>
+          <p:cNvPr id="32" name="tile body 5"/>
+          <p:cNvSpPr txBox="1"/>
+          <p:nvPr/>
+        </p:nvSpPr>
+        <p:spPr>
+          <a:xfrm>
+            <a:off x="8366760" y="5029200"/>
+            <a:ext cx="2971800" cy="731520"/>
+          </a:xfrm>
+          <a:prstGeom prst="rect">
+            <a:avLst/>
+          </a:prstGeom>
+          <a:noFill/>
+          <a:ln/>
+        </p:spPr>
+        <p:txBody>
+          <a:bodyPr wrap="square" lIns="0" tIns="0" rIns="0" bIns="0" rtlCol="0" anchor="t"/>
+          <a:lstStyle/>
+          <a:p>
+            <a:pPr indent="0" marL="0">
+              <a:buNone/>
+            </a:pPr>
+            <a:r>
+              <a:rPr lang="en-US" sz="1500" dirty="0">
+                <a:solidFill>
+                  <a:schemeClr val="tx2"/>
+                </a:solidFill>
+              </a:rPr>
+              <a:t>Povrch hladký na jednotky nanometrů</a:t>
+            </a:r>
+            <a:endParaRPr lang="en-US" sz="1500" dirty="0"/>
           </a:p>
         </p:txBody>
       </p:sp>
@@ -3544,7 +3882,7 @@
                   <a:schemeClr val="tx1"/>
                 </a:solidFill>
               </a:rPr>
-              <a:t>Jak vypadá soustružení dnes</a:t>
+              <a:t>1 · Hybridní stroje: 3D tisk + obrábění</a:t>
             </a:r>
             <a:endParaRPr lang="en-US" sz="3400" dirty="0"/>
           </a:p>
@@ -3552,18 +3890,18 @@
       </p:sp>
       <p:sp>
         <p:nvSpPr>
-          <p:cNvPr id="3" name="card 0"/>
+          <p:cNvPr id="3" name="step 0"/>
           <p:cNvSpPr/>
           <p:nvPr/>
         </p:nvSpPr>
         <p:spPr>
           <a:xfrm>
-            <a:off x="548640" y="1508760"/>
-            <a:ext cx="3520440" cy="4023360"/>
+            <a:off x="548640" y="1463040"/>
+            <a:ext cx="3383280" cy="2011680"/>
           </a:xfrm>
           <a:prstGeom prst="roundRect">
             <a:avLst>
-              <a:gd name="adj" fmla="val 3117"/>
+              <a:gd name="adj" fmla="val 5455"/>
             </a:avLst>
           </a:prstGeom>
           <a:solidFill>
@@ -3574,14 +3912,14 @@
       </p:sp>
       <p:sp>
         <p:nvSpPr>
-          <p:cNvPr id="4" name="icon 0 circle"/>
+          <p:cNvPr id="4" name="step icon 0 circle"/>
           <p:cNvSpPr/>
           <p:nvPr/>
         </p:nvSpPr>
         <p:spPr>
           <a:xfrm>
-            <a:off x="914400" y="1874520"/>
-            <a:ext cx="914400" cy="914400"/>
+            <a:off x="822960" y="1691640"/>
+            <a:ext cx="731520" cy="731520"/>
           </a:xfrm>
           <a:prstGeom prst="ellipse">
             <a:avLst/>
@@ -3594,7 +3932,7 @@
       </p:sp>
       <p:pic>
         <p:nvPicPr>
-          <p:cNvPr id="5" name="icon 0" descr="icon 0">    </p:cNvPr>
+          <p:cNvPr id="5" name="step icon 0" descr="step icon 0">    </p:cNvPr>
           <p:cNvPicPr>
             <a:picLocks noChangeAspect="1"/>
           </p:cNvPicPr>
@@ -3608,8 +3946,8 @@
         </p:blipFill>
         <p:spPr>
           <a:xfrm>
-            <a:off x="1115568" y="2075688"/>
-            <a:ext cx="512064" cy="512064"/>
+            <a:off x="983894" y="1852574"/>
+            <a:ext cx="409651" cy="409651"/>
           </a:xfrm>
           <a:prstGeom prst="rect">
             <a:avLst/>
@@ -3618,14 +3956,50 @@
       </p:pic>
       <p:sp>
         <p:nvSpPr>
-          <p:cNvPr id="6" name="card title 0"/>
-          <p:cNvSpPr txBox="1"/>
-          <p:nvPr/>
-        </p:nvSpPr>
-        <p:spPr>
-          <a:xfrm>
-            <a:off x="914400" y="3017520"/>
-            <a:ext cx="2834640" cy="822960"/>
+          <p:cNvPr id="6" name="step title 0"/>
+          <p:cNvSpPr txBox="1"/>
+          <p:nvPr/>
+        </p:nvSpPr>
+        <p:spPr>
+          <a:xfrm>
+            <a:off x="1737360" y="1691640"/>
+            <a:ext cx="2011680" cy="731520"/>
+          </a:xfrm>
+          <a:prstGeom prst="rect">
+            <a:avLst/>
+          </a:prstGeom>
+          <a:noFill/>
+          <a:ln/>
+        </p:spPr>
+        <p:txBody>
+          <a:bodyPr wrap="square" lIns="0" tIns="0" rIns="0" bIns="0" rtlCol="0" anchor="ctr"/>
+          <a:lstStyle/>
+          <a:p>
+            <a:pPr indent="0" marL="0">
+              <a:buNone/>
+            </a:pPr>
+            <a:r>
+              <a:rPr lang="en-US" sz="2000" b="1" dirty="0">
+                <a:solidFill>
+                  <a:schemeClr val="tx1"/>
+                </a:solidFill>
+              </a:rPr>
+              <a:t>Natisknout</a:t>
+            </a:r>
+            <a:endParaRPr lang="en-US" sz="2000" dirty="0"/>
+          </a:p>
+        </p:txBody>
+      </p:sp>
+      <p:sp>
+        <p:nvSpPr>
+          <p:cNvPr id="7" name="step body 0"/>
+          <p:cNvSpPr txBox="1"/>
+          <p:nvPr/>
+        </p:nvSpPr>
+        <p:spPr>
+          <a:xfrm>
+            <a:off x="822960" y="2560320"/>
+            <a:ext cx="2880360" cy="868680"/>
           </a:xfrm>
           <a:prstGeom prst="rect">
             <a:avLst/>
@@ -3641,98 +4015,20 @@
               <a:buNone/>
             </a:pPr>
             <a:r>
-              <a:rPr lang="en-US" sz="2000" b="1" dirty="0">
-                <a:solidFill>
-                  <a:schemeClr val="tx1"/>
-                </a:solidFill>
-              </a:rPr>
-              <a:t>Soustružnicko-frézovací centra</a:t>
-            </a:r>
-            <a:endParaRPr lang="en-US" sz="2000" dirty="0"/>
-          </a:p>
-        </p:txBody>
-      </p:sp>
-      <p:sp>
-        <p:nvSpPr>
-          <p:cNvPr id="7" name="card body 0"/>
-          <p:cNvSpPr txBox="1"/>
-          <p:nvPr/>
-        </p:nvSpPr>
-        <p:spPr>
-          <a:xfrm>
-            <a:off x="914400" y="3931920"/>
-            <a:ext cx="2834640" cy="1463040"/>
-          </a:xfrm>
-          <a:prstGeom prst="rect">
-            <a:avLst/>
-          </a:prstGeom>
-          <a:noFill/>
-          <a:ln/>
-        </p:spPr>
-        <p:txBody>
-          <a:bodyPr wrap="square" lIns="0" tIns="0" rIns="0" bIns="0" rtlCol="0" anchor="t"/>
-          <a:lstStyle/>
-          <a:p>
-            <a:pPr indent="0" marL="0">
-              <a:buNone/>
-            </a:pPr>
-            <a:r>
-              <a:rPr lang="en-US" sz="1600" dirty="0">
+              <a:rPr lang="en-US" sz="1400" dirty="0">
                 <a:solidFill>
                   <a:schemeClr val="tx2"/>
                 </a:solidFill>
               </a:rPr>
-              <a:t>Jeden stroj soustruží, frézuje i vrtá. Složitý díl je hotový na jedno upnutí.</a:t>
-            </a:r>
-            <a:endParaRPr lang="en-US" sz="1600" dirty="0"/>
-          </a:p>
-        </p:txBody>
-      </p:sp>
-      <p:sp>
-        <p:nvSpPr>
-          <p:cNvPr id="8" name="card 1"/>
-          <p:cNvSpPr/>
-          <p:nvPr/>
-        </p:nvSpPr>
-        <p:spPr>
-          <a:xfrm>
-            <a:off x="4320540" y="1508760"/>
-            <a:ext cx="3520440" cy="4023360"/>
-          </a:xfrm>
-          <a:prstGeom prst="roundRect">
-            <a:avLst>
-              <a:gd name="adj" fmla="val 3117"/>
-            </a:avLst>
-          </a:prstGeom>
-          <a:solidFill>
-            <a:schemeClr val="bg2"/>
-          </a:solidFill>
-          <a:ln/>
-        </p:spPr>
-      </p:sp>
-      <p:sp>
-        <p:nvSpPr>
-          <p:cNvPr id="9" name="icon 1 circle"/>
-          <p:cNvSpPr/>
-          <p:nvPr/>
-        </p:nvSpPr>
-        <p:spPr>
-          <a:xfrm>
-            <a:off x="4686300" y="1874520"/>
-            <a:ext cx="914400" cy="914400"/>
-          </a:xfrm>
-          <a:prstGeom prst="ellipse">
-            <a:avLst/>
-          </a:prstGeom>
-          <a:solidFill>
-            <a:schemeClr val="accent1"/>
-          </a:solidFill>
-          <a:ln/>
-        </p:spPr>
+              <a:t>Laser taví kovový prášek a vrstvu po vrstvě staví hrubý tvar (DED)</a:t>
+            </a:r>
+            <a:endParaRPr lang="en-US" sz="1400" dirty="0"/>
+          </a:p>
+        </p:txBody>
       </p:sp>
       <p:pic>
         <p:nvPicPr>
-          <p:cNvPr id="10" name="icon 1" descr="icon 1">    </p:cNvPr>
+          <p:cNvPr id="8" name="arrow 0" descr="šipka">    </p:cNvPr>
           <p:cNvPicPr>
             <a:picLocks noChangeAspect="1"/>
           </p:cNvPicPr>
@@ -3746,8 +4042,8 @@
         </p:blipFill>
         <p:spPr>
           <a:xfrm>
-            <a:off x="4887468" y="2075688"/>
-            <a:ext cx="512064" cy="512064"/>
+            <a:off x="4005072" y="2267712"/>
+            <a:ext cx="384048" cy="384048"/>
           </a:xfrm>
           <a:prstGeom prst="rect">
             <a:avLst/>
@@ -3756,90 +4052,18 @@
       </p:pic>
       <p:sp>
         <p:nvSpPr>
-          <p:cNvPr id="11" name="card title 1"/>
-          <p:cNvSpPr txBox="1"/>
-          <p:nvPr/>
-        </p:nvSpPr>
-        <p:spPr>
-          <a:xfrm>
-            <a:off x="4686300" y="3017520"/>
-            <a:ext cx="2834640" cy="822960"/>
-          </a:xfrm>
-          <a:prstGeom prst="rect">
-            <a:avLst/>
-          </a:prstGeom>
-          <a:noFill/>
-          <a:ln/>
-        </p:spPr>
-        <p:txBody>
-          <a:bodyPr wrap="square" lIns="0" tIns="0" rIns="0" bIns="0" rtlCol="0" anchor="t"/>
-          <a:lstStyle/>
-          <a:p>
-            <a:pPr indent="0" marL="0">
-              <a:buNone/>
-            </a:pPr>
-            <a:r>
-              <a:rPr lang="en-US" sz="2000" b="1" dirty="0">
-                <a:solidFill>
-                  <a:schemeClr val="tx1"/>
-                </a:solidFill>
-              </a:rPr>
-              <a:t>Osa Y a poháněné nástroje</a:t>
-            </a:r>
-            <a:endParaRPr lang="en-US" sz="2000" dirty="0"/>
-          </a:p>
-        </p:txBody>
-      </p:sp>
-      <p:sp>
-        <p:nvSpPr>
-          <p:cNvPr id="12" name="card body 1"/>
-          <p:cNvSpPr txBox="1"/>
-          <p:nvPr/>
-        </p:nvSpPr>
-        <p:spPr>
-          <a:xfrm>
-            <a:off x="4686300" y="3931920"/>
-            <a:ext cx="2834640" cy="1463040"/>
-          </a:xfrm>
-          <a:prstGeom prst="rect">
-            <a:avLst/>
-          </a:prstGeom>
-          <a:noFill/>
-          <a:ln/>
-        </p:spPr>
-        <p:txBody>
-          <a:bodyPr wrap="square" lIns="0" tIns="0" rIns="0" bIns="0" rtlCol="0" anchor="t"/>
-          <a:lstStyle/>
-          <a:p>
-            <a:pPr indent="0" marL="0">
-              <a:buNone/>
-            </a:pPr>
-            <a:r>
-              <a:rPr lang="en-US" sz="1600" dirty="0">
-                <a:solidFill>
-                  <a:schemeClr val="tx2"/>
-                </a:solidFill>
-              </a:rPr>
-              <a:t>Nástroje se pohybují mimo osu obrobku i se samy otáčejí, takže vzniknou drážky, díry i plošky.</a:t>
-            </a:r>
-            <a:endParaRPr lang="en-US" sz="1600" dirty="0"/>
-          </a:p>
-        </p:txBody>
-      </p:sp>
-      <p:sp>
-        <p:nvSpPr>
-          <p:cNvPr id="13" name="card 2"/>
+          <p:cNvPr id="9" name="step 1"/>
           <p:cNvSpPr/>
           <p:nvPr/>
         </p:nvSpPr>
         <p:spPr>
           <a:xfrm>
-            <a:off x="8092440" y="1508760"/>
-            <a:ext cx="3520440" cy="4023360"/>
+            <a:off x="4389120" y="1463040"/>
+            <a:ext cx="3383280" cy="2011680"/>
           </a:xfrm>
           <a:prstGeom prst="roundRect">
             <a:avLst>
-              <a:gd name="adj" fmla="val 3117"/>
+              <a:gd name="adj" fmla="val 5455"/>
             </a:avLst>
           </a:prstGeom>
           <a:solidFill>
@@ -3850,14 +4074,14 @@
       </p:sp>
       <p:sp>
         <p:nvSpPr>
-          <p:cNvPr id="14" name="icon 2 circle"/>
+          <p:cNvPr id="10" name="step icon 1 circle"/>
           <p:cNvSpPr/>
           <p:nvPr/>
         </p:nvSpPr>
         <p:spPr>
           <a:xfrm>
-            <a:off x="8458200" y="1874520"/>
-            <a:ext cx="914400" cy="914400"/>
+            <a:off x="4663440" y="1691640"/>
+            <a:ext cx="731520" cy="731520"/>
           </a:xfrm>
           <a:prstGeom prst="ellipse">
             <a:avLst/>
@@ -3870,7 +4094,7 @@
       </p:sp>
       <p:pic>
         <p:nvPicPr>
-          <p:cNvPr id="15" name="icon 2" descr="icon 2">    </p:cNvPr>
+          <p:cNvPr id="11" name="step icon 1" descr="step icon 1">    </p:cNvPr>
           <p:cNvPicPr>
             <a:picLocks noChangeAspect="1"/>
           </p:cNvPicPr>
@@ -3884,8 +4108,8 @@
         </p:blipFill>
         <p:spPr>
           <a:xfrm>
-            <a:off x="8659368" y="2075688"/>
-            <a:ext cx="512064" cy="512064"/>
+            <a:off x="4824374" y="1852574"/>
+            <a:ext cx="409651" cy="409651"/>
           </a:xfrm>
           <a:prstGeom prst="rect">
             <a:avLst/>
@@ -3894,14 +4118,50 @@
       </p:pic>
       <p:sp>
         <p:nvSpPr>
-          <p:cNvPr id="16" name="card title 2"/>
-          <p:cNvSpPr txBox="1"/>
-          <p:nvPr/>
-        </p:nvSpPr>
-        <p:spPr>
-          <a:xfrm>
-            <a:off x="8458200" y="3017520"/>
-            <a:ext cx="2834640" cy="822960"/>
+          <p:cNvPr id="12" name="step title 1"/>
+          <p:cNvSpPr txBox="1"/>
+          <p:nvPr/>
+        </p:nvSpPr>
+        <p:spPr>
+          <a:xfrm>
+            <a:off x="5577840" y="1691640"/>
+            <a:ext cx="2011680" cy="731520"/>
+          </a:xfrm>
+          <a:prstGeom prst="rect">
+            <a:avLst/>
+          </a:prstGeom>
+          <a:noFill/>
+          <a:ln/>
+        </p:spPr>
+        <p:txBody>
+          <a:bodyPr wrap="square" lIns="0" tIns="0" rIns="0" bIns="0" rtlCol="0" anchor="ctr"/>
+          <a:lstStyle/>
+          <a:p>
+            <a:pPr indent="0" marL="0">
+              <a:buNone/>
+            </a:pPr>
+            <a:r>
+              <a:rPr lang="en-US" sz="2000" b="1" dirty="0">
+                <a:solidFill>
+                  <a:schemeClr val="tx1"/>
+                </a:solidFill>
+              </a:rPr>
+              <a:t>Obrobit</a:t>
+            </a:r>
+            <a:endParaRPr lang="en-US" sz="2000" dirty="0"/>
+          </a:p>
+        </p:txBody>
+      </p:sp>
+      <p:sp>
+        <p:nvSpPr>
+          <p:cNvPr id="13" name="step body 1"/>
+          <p:cNvSpPr txBox="1"/>
+          <p:nvPr/>
+        </p:nvSpPr>
+        <p:spPr>
+          <a:xfrm>
+            <a:off x="4663440" y="2560320"/>
+            <a:ext cx="2880360" cy="868680"/>
           </a:xfrm>
           <a:prstGeom prst="rect">
             <a:avLst/>
@@ -3917,12 +4177,138 @@
               <a:buNone/>
             </a:pPr>
             <a:r>
+              <a:rPr lang="en-US" sz="1400" dirty="0">
+                <a:solidFill>
+                  <a:schemeClr val="tx2"/>
+                </a:solidFill>
+              </a:rPr>
+              <a:t>Soustružnické a frézovací vřeteno dorobí díl na přesný rozměr</a:t>
+            </a:r>
+            <a:endParaRPr lang="en-US" sz="1400" dirty="0"/>
+          </a:p>
+        </p:txBody>
+      </p:sp>
+      <p:pic>
+        <p:nvPicPr>
+          <p:cNvPr id="14" name="arrow 1" descr="šipka">    </p:cNvPr>
+          <p:cNvPicPr>
+            <a:picLocks noChangeAspect="1"/>
+          </p:cNvPicPr>
+          <p:nvPr/>
+        </p:nvPicPr>
+        <p:blipFill>
+          <a:blip r:embed="rId4"/>
+          <a:stretch>
+            <a:fillRect/>
+          </a:stretch>
+        </p:blipFill>
+        <p:spPr>
+          <a:xfrm>
+            <a:off x="7845552" y="2267712"/>
+            <a:ext cx="384048" cy="384048"/>
+          </a:xfrm>
+          <a:prstGeom prst="rect">
+            <a:avLst/>
+          </a:prstGeom>
+        </p:spPr>
+      </p:pic>
+      <p:sp>
+        <p:nvSpPr>
+          <p:cNvPr id="15" name="step 2"/>
+          <p:cNvSpPr/>
+          <p:nvPr/>
+        </p:nvSpPr>
+        <p:spPr>
+          <a:xfrm>
+            <a:off x="8229600" y="1463040"/>
+            <a:ext cx="3383280" cy="2011680"/>
+          </a:xfrm>
+          <a:prstGeom prst="roundRect">
+            <a:avLst>
+              <a:gd name="adj" fmla="val 5455"/>
+            </a:avLst>
+          </a:prstGeom>
+          <a:solidFill>
+            <a:schemeClr val="bg2"/>
+          </a:solidFill>
+          <a:ln/>
+        </p:spPr>
+      </p:sp>
+      <p:sp>
+        <p:nvSpPr>
+          <p:cNvPr id="16" name="step icon 2 circle"/>
+          <p:cNvSpPr/>
+          <p:nvPr/>
+        </p:nvSpPr>
+        <p:spPr>
+          <a:xfrm>
+            <a:off x="8503920" y="1691640"/>
+            <a:ext cx="731520" cy="731520"/>
+          </a:xfrm>
+          <a:prstGeom prst="ellipse">
+            <a:avLst/>
+          </a:prstGeom>
+          <a:solidFill>
+            <a:schemeClr val="accent1"/>
+          </a:solidFill>
+          <a:ln/>
+        </p:spPr>
+      </p:sp>
+      <p:pic>
+        <p:nvPicPr>
+          <p:cNvPr id="17" name="step icon 2" descr="step icon 2">    </p:cNvPr>
+          <p:cNvPicPr>
+            <a:picLocks noChangeAspect="1"/>
+          </p:cNvPicPr>
+          <p:nvPr/>
+        </p:nvPicPr>
+        <p:blipFill>
+          <a:blip r:embed="rId5"/>
+          <a:stretch>
+            <a:fillRect/>
+          </a:stretch>
+        </p:blipFill>
+        <p:spPr>
+          <a:xfrm>
+            <a:off x="8664854" y="1852574"/>
+            <a:ext cx="409651" cy="409651"/>
+          </a:xfrm>
+          <a:prstGeom prst="rect">
+            <a:avLst/>
+          </a:prstGeom>
+        </p:spPr>
+      </p:pic>
+      <p:sp>
+        <p:nvSpPr>
+          <p:cNvPr id="18" name="step title 2"/>
+          <p:cNvSpPr txBox="1"/>
+          <p:nvPr/>
+        </p:nvSpPr>
+        <p:spPr>
+          <a:xfrm>
+            <a:off x="9418320" y="1691640"/>
+            <a:ext cx="2011680" cy="731520"/>
+          </a:xfrm>
+          <a:prstGeom prst="rect">
+            <a:avLst/>
+          </a:prstGeom>
+          <a:noFill/>
+          <a:ln/>
+        </p:spPr>
+        <p:txBody>
+          <a:bodyPr wrap="square" lIns="0" tIns="0" rIns="0" bIns="0" rtlCol="0" anchor="ctr"/>
+          <a:lstStyle/>
+          <a:p>
+            <a:pPr indent="0" marL="0">
+              <a:buNone/>
+            </a:pPr>
+            <a:r>
               <a:rPr lang="en-US" sz="2000" b="1" dirty="0">
                 <a:solidFill>
                   <a:schemeClr val="tx1"/>
                 </a:solidFill>
               </a:rPr>
-              <a:t>Dlouhotočné automaty</a:t>
+              <a:t>Hotovo</a:t>
             </a:r>
             <a:endParaRPr lang="en-US" sz="2000" dirty="0"/>
           </a:p>
@@ -3930,14 +4316,14 @@
       </p:sp>
       <p:sp>
         <p:nvSpPr>
-          <p:cNvPr id="17" name="card body 2"/>
-          <p:cNvSpPr txBox="1"/>
-          <p:nvPr/>
-        </p:nvSpPr>
-        <p:spPr>
-          <a:xfrm>
-            <a:off x="8458200" y="3931920"/>
-            <a:ext cx="2834640" cy="1463040"/>
+          <p:cNvPr id="19" name="step body 2"/>
+          <p:cNvSpPr txBox="1"/>
+          <p:nvPr/>
+        </p:nvSpPr>
+        <p:spPr>
+          <a:xfrm>
+            <a:off x="8503920" y="2560320"/>
+            <a:ext cx="2880360" cy="868680"/>
           </a:xfrm>
           <a:prstGeom prst="rect">
             <a:avLst/>
@@ -3953,14 +4339,260 @@
               <a:buNone/>
             </a:pPr>
             <a:r>
-              <a:rPr lang="en-US" sz="1600" dirty="0">
+              <a:rPr lang="en-US" sz="1400" dirty="0">
                 <a:solidFill>
                   <a:schemeClr val="tx2"/>
                 </a:solidFill>
               </a:rPr>
-              <a:t>Tzv. Swiss-type pro drobné přesné díly: šroubky do implantátů, součástky hodinek, konektory.</a:t>
-            </a:r>
-            <a:endParaRPr lang="en-US" sz="1600" dirty="0"/>
+              <a:t>Vše na jedno upnutí, bez přenášení mezi stroji</a:t>
+            </a:r>
+            <a:endParaRPr lang="en-US" sz="1400" dirty="0"/>
+          </a:p>
+        </p:txBody>
+      </p:sp>
+      <p:sp>
+        <p:nvSpPr>
+          <p:cNvPr id="20" name="why title"/>
+          <p:cNvSpPr txBox="1"/>
+          <p:nvPr/>
+        </p:nvSpPr>
+        <p:spPr>
+          <a:xfrm>
+            <a:off x="548640" y="3840480"/>
+            <a:ext cx="6400800" cy="457200"/>
+          </a:xfrm>
+          <a:prstGeom prst="rect">
+            <a:avLst/>
+          </a:prstGeom>
+          <a:noFill/>
+          <a:ln/>
+        </p:spPr>
+        <p:txBody>
+          <a:bodyPr wrap="square" lIns="0" tIns="0" rIns="0" bIns="0" rtlCol="0" anchor="t"/>
+          <a:lstStyle/>
+          <a:p>
+            <a:pPr indent="0" marL="0">
+              <a:buNone/>
+            </a:pPr>
+            <a:r>
+              <a:rPr lang="en-US" sz="2000" b="1" dirty="0">
+                <a:solidFill>
+                  <a:schemeClr val="tx1"/>
+                </a:solidFill>
+              </a:rPr>
+              <a:t>Proč je to užitečné</a:t>
+            </a:r>
+            <a:endParaRPr lang="en-US" sz="2000" dirty="0"/>
+          </a:p>
+        </p:txBody>
+      </p:sp>
+      <p:sp>
+        <p:nvSpPr>
+          <p:cNvPr id="21" name="why list"/>
+          <p:cNvSpPr txBox="1"/>
+          <p:nvPr/>
+        </p:nvSpPr>
+        <p:spPr>
+          <a:xfrm>
+            <a:off x="548640" y="4389120"/>
+            <a:ext cx="6675120" cy="1737360"/>
+          </a:xfrm>
+          <a:prstGeom prst="rect">
+            <a:avLst/>
+          </a:prstGeom>
+          <a:noFill/>
+          <a:ln/>
+        </p:spPr>
+        <p:txBody>
+          <a:bodyPr wrap="square" lIns="0" tIns="0" rIns="0" bIns="0" rtlCol="0" anchor="t"/>
+          <a:lstStyle/>
+          <a:p>
+            <a:pPr marL="228600" indent="-228600">
+              <a:spcAft>
+                <a:spcPts val="800"/>
+              </a:spcAft>
+              <a:buSzPct val="100000"/>
+              <a:buChar char="•"/>
+            </a:pPr>
+            <a:r>
+              <a:rPr lang="en-US" sz="1500" dirty="0">
+                <a:solidFill>
+                  <a:schemeClr val="tx2"/>
+                </a:solidFill>
+              </a:rPr>
+              <a:t>Vyšší přesnost: díl se mezi kroky nepřepíná</a:t>
+            </a:r>
+            <a:endParaRPr lang="en-US" sz="1500" dirty="0"/>
+          </a:p>
+          <a:p>
+            <a:pPr marL="228600" indent="-228600">
+              <a:spcAft>
+                <a:spcPts val="800"/>
+              </a:spcAft>
+              <a:buSzPct val="100000"/>
+              <a:buChar char="•"/>
+            </a:pPr>
+            <a:r>
+              <a:rPr lang="en-US" sz="1500" dirty="0">
+                <a:solidFill>
+                  <a:schemeClr val="tx2"/>
+                </a:solidFill>
+              </a:rPr>
+              <a:t>Méně odpadu: materiál se přidává jen tam, kde je potřeba</a:t>
+            </a:r>
+            <a:endParaRPr lang="en-US" sz="1500" dirty="0"/>
+          </a:p>
+          <a:p>
+            <a:pPr marL="228600" indent="-228600">
+              <a:spcAft>
+                <a:spcPts val="800"/>
+              </a:spcAft>
+              <a:buSzPct val="100000"/>
+              <a:buChar char="•"/>
+            </a:pPr>
+            <a:r>
+              <a:rPr lang="en-US" sz="1500" dirty="0">
+                <a:solidFill>
+                  <a:schemeClr val="tx2"/>
+                </a:solidFill>
+              </a:rPr>
+              <a:t>Opravy drahých dílů: navaření a obrobení opotřebené lopatky turbíny</a:t>
+            </a:r>
+            <a:endParaRPr lang="en-US" sz="1500" dirty="0"/>
+          </a:p>
+        </p:txBody>
+      </p:sp>
+      <p:sp>
+        <p:nvSpPr>
+          <p:cNvPr id="22" name="examples card"/>
+          <p:cNvSpPr/>
+          <p:nvPr/>
+        </p:nvSpPr>
+        <p:spPr>
+          <a:xfrm>
+            <a:off x="7589520" y="3840480"/>
+            <a:ext cx="4023360" cy="2194560"/>
+          </a:xfrm>
+          <a:prstGeom prst="roundRect">
+            <a:avLst>
+              <a:gd name="adj" fmla="val 5000"/>
+            </a:avLst>
+          </a:prstGeom>
+          <a:solidFill>
+            <a:schemeClr val="tx1"/>
+          </a:solidFill>
+          <a:ln/>
+        </p:spPr>
+      </p:sp>
+      <p:sp>
+        <p:nvSpPr>
+          <p:cNvPr id="23" name="ex title"/>
+          <p:cNvSpPr txBox="1"/>
+          <p:nvPr/>
+        </p:nvSpPr>
+        <p:spPr>
+          <a:xfrm>
+            <a:off x="7863840" y="4023360"/>
+            <a:ext cx="3566160" cy="411480"/>
+          </a:xfrm>
+          <a:prstGeom prst="rect">
+            <a:avLst/>
+          </a:prstGeom>
+          <a:noFill/>
+          <a:ln/>
+        </p:spPr>
+        <p:txBody>
+          <a:bodyPr wrap="square" lIns="0" tIns="0" rIns="0" bIns="0" rtlCol="0" anchor="t"/>
+          <a:lstStyle/>
+          <a:p>
+            <a:pPr indent="0" marL="0">
+              <a:buNone/>
+            </a:pPr>
+            <a:r>
+              <a:rPr lang="en-US" sz="1800" b="1" dirty="0">
+                <a:solidFill>
+                  <a:schemeClr val="accent1"/>
+                </a:solidFill>
+              </a:rPr>
+              <a:t>Příklady strojů</a:t>
+            </a:r>
+            <a:endParaRPr lang="en-US" sz="1800" dirty="0"/>
+          </a:p>
+        </p:txBody>
+      </p:sp>
+      <p:sp>
+        <p:nvSpPr>
+          <p:cNvPr id="24" name="ex list"/>
+          <p:cNvSpPr txBox="1"/>
+          <p:nvPr/>
+        </p:nvSpPr>
+        <p:spPr>
+          <a:xfrm>
+            <a:off x="7863840" y="4526280"/>
+            <a:ext cx="3566160" cy="1371600"/>
+          </a:xfrm>
+          <a:prstGeom prst="rect">
+            <a:avLst/>
+          </a:prstGeom>
+          <a:noFill/>
+          <a:ln/>
+        </p:spPr>
+        <p:txBody>
+          <a:bodyPr wrap="square" lIns="0" tIns="0" rIns="0" bIns="0" rtlCol="0" anchor="t"/>
+          <a:lstStyle/>
+          <a:p>
+            <a:pPr marL="228600" indent="-228600">
+              <a:spcAft>
+                <a:spcPts val="600"/>
+              </a:spcAft>
+              <a:buSzPct val="100000"/>
+              <a:buChar char="•"/>
+            </a:pPr>
+            <a:r>
+              <a:rPr lang="en-US" sz="1500" dirty="0">
+                <a:solidFill>
+                  <a:schemeClr val="bg1"/>
+                </a:solidFill>
+              </a:rPr>
+              <a:t>Okuma LASER EX</a:t>
+            </a:r>
+            <a:endParaRPr lang="en-US" sz="1500" dirty="0"/>
+          </a:p>
+          <a:p>
+            <a:pPr marL="228600" indent="-228600">
+              <a:spcAft>
+                <a:spcPts val="600"/>
+              </a:spcAft>
+              <a:buSzPct val="100000"/>
+              <a:buChar char="•"/>
+            </a:pPr>
+            <a:r>
+              <a:rPr lang="en-US" sz="1500" dirty="0">
+                <a:solidFill>
+                  <a:schemeClr val="bg1"/>
+                </a:solidFill>
+              </a:rPr>
+              <a:t>DMG MORI LASERTEC DED hybrid</a:t>
+            </a:r>
+            <a:endParaRPr lang="en-US" sz="1500" dirty="0"/>
+          </a:p>
+          <a:p>
+            <a:pPr marL="228600" indent="-228600">
+              <a:spcAft>
+                <a:spcPts val="600"/>
+              </a:spcAft>
+              <a:buSzPct val="100000"/>
+              <a:buChar char="•"/>
+            </a:pPr>
+            <a:r>
+              <a:rPr lang="en-US" sz="1500" dirty="0">
+                <a:solidFill>
+                  <a:schemeClr val="bg1"/>
+                </a:solidFill>
+              </a:rPr>
+              <a:t>Mazak INTEGREX i-AM</a:t>
+            </a:r>
+            <a:endParaRPr lang="en-US" sz="1500" dirty="0"/>
           </a:p>
         </p:txBody>
       </p:sp>
@@ -4066,7 +4698,7 @@
                   <a:schemeClr val="tx1"/>
                 </a:solidFill>
               </a:rPr>
-              <a:t>1 · Hybridní stroje: 3D tisk + obrábění</a:t>
+              <a:t>2 · Kryogenní obrábění: chlazení tekutým dusíkem</a:t>
             </a:r>
             <a:endParaRPr lang="en-US" sz="3400" dirty="0"/>
           </a:p>
@@ -4074,18 +4706,18 @@
       </p:sp>
       <p:sp>
         <p:nvSpPr>
-          <p:cNvPr id="3" name="step 0"/>
+          <p:cNvPr id="3" name="stat 0"/>
           <p:cNvSpPr/>
           <p:nvPr/>
         </p:nvSpPr>
         <p:spPr>
           <a:xfrm>
             <a:off x="548640" y="1463040"/>
-            <a:ext cx="3383280" cy="2011680"/>
+            <a:ext cx="3520440" cy="1828800"/>
           </a:xfrm>
           <a:prstGeom prst="roundRect">
             <a:avLst>
-              <a:gd name="adj" fmla="val 5455"/>
+              <a:gd name="adj" fmla="val 6000"/>
             </a:avLst>
           </a:prstGeom>
           <a:solidFill>
@@ -4096,27 +4728,296 @@
       </p:sp>
       <p:sp>
         <p:nvSpPr>
-          <p:cNvPr id="4" name="step icon 0 circle"/>
+          <p:cNvPr id="4" name="stat value 0"/>
+          <p:cNvSpPr txBox="1"/>
+          <p:nvPr/>
+        </p:nvSpPr>
+        <p:spPr>
+          <a:xfrm>
+            <a:off x="822960" y="1600200"/>
+            <a:ext cx="3017520" cy="868680"/>
+          </a:xfrm>
+          <a:prstGeom prst="rect">
+            <a:avLst/>
+          </a:prstGeom>
+          <a:noFill/>
+          <a:ln/>
+        </p:spPr>
+        <p:txBody>
+          <a:bodyPr wrap="square" lIns="0" tIns="0" rIns="0" bIns="0" rtlCol="0" anchor="t"/>
+          <a:lstStyle/>
+          <a:p>
+            <a:pPr indent="0" marL="0">
+              <a:buNone/>
+            </a:pPr>
+            <a:r>
+              <a:rPr lang="en-US" sz="4400" b="1" dirty="0">
+                <a:solidFill>
+                  <a:schemeClr val="accent2"/>
+                </a:solidFill>
+                <a:latin typeface="Arial" pitchFamily="34" charset="0"/>
+                <a:ea typeface="Arial" pitchFamily="34" charset="-122"/>
+                <a:cs typeface="Arial" pitchFamily="34" charset="-120"/>
+              </a:rPr>
+              <a:t>−196 °C</a:t>
+            </a:r>
+            <a:endParaRPr lang="en-US" sz="4400" dirty="0"/>
+          </a:p>
+        </p:txBody>
+      </p:sp>
+      <p:sp>
+        <p:nvSpPr>
+          <p:cNvPr id="5" name="stat label 0"/>
+          <p:cNvSpPr txBox="1"/>
+          <p:nvPr/>
+        </p:nvSpPr>
+        <p:spPr>
+          <a:xfrm>
+            <a:off x="822960" y="2514600"/>
+            <a:ext cx="3017520" cy="685800"/>
+          </a:xfrm>
+          <a:prstGeom prst="rect">
+            <a:avLst/>
+          </a:prstGeom>
+          <a:noFill/>
+          <a:ln/>
+        </p:spPr>
+        <p:txBody>
+          <a:bodyPr wrap="square" lIns="0" tIns="0" rIns="0" bIns="0" rtlCol="0" anchor="t"/>
+          <a:lstStyle/>
+          <a:p>
+            <a:pPr indent="0" marL="0">
+              <a:buNone/>
+            </a:pPr>
+            <a:r>
+              <a:rPr lang="en-US" sz="1400" dirty="0">
+                <a:solidFill>
+                  <a:schemeClr val="tx2"/>
+                </a:solidFill>
+              </a:rPr>
+              <a:t>tekutý dusík (LN₂) stříkaný přímo na břit</a:t>
+            </a:r>
+            <a:endParaRPr lang="en-US" sz="1400" dirty="0"/>
+          </a:p>
+        </p:txBody>
+      </p:sp>
+      <p:sp>
+        <p:nvSpPr>
+          <p:cNvPr id="6" name="stat 1"/>
           <p:cNvSpPr/>
           <p:nvPr/>
         </p:nvSpPr>
         <p:spPr>
           <a:xfrm>
-            <a:off x="822960" y="1691640"/>
-            <a:ext cx="731520" cy="731520"/>
+            <a:off x="4320540" y="1463040"/>
+            <a:ext cx="3520440" cy="1828800"/>
+          </a:xfrm>
+          <a:prstGeom prst="roundRect">
+            <a:avLst>
+              <a:gd name="adj" fmla="val 6000"/>
+            </a:avLst>
+          </a:prstGeom>
+          <a:solidFill>
+            <a:schemeClr val="bg2"/>
+          </a:solidFill>
+          <a:ln/>
+        </p:spPr>
+      </p:sp>
+      <p:sp>
+        <p:nvSpPr>
+          <p:cNvPr id="7" name="stat value 1"/>
+          <p:cNvSpPr txBox="1"/>
+          <p:nvPr/>
+        </p:nvSpPr>
+        <p:spPr>
+          <a:xfrm>
+            <a:off x="4594860" y="1600200"/>
+            <a:ext cx="3017520" cy="868680"/>
+          </a:xfrm>
+          <a:prstGeom prst="rect">
+            <a:avLst/>
+          </a:prstGeom>
+          <a:noFill/>
+          <a:ln/>
+        </p:spPr>
+        <p:txBody>
+          <a:bodyPr wrap="square" lIns="0" tIns="0" rIns="0" bIns="0" rtlCol="0" anchor="t"/>
+          <a:lstStyle/>
+          <a:p>
+            <a:pPr indent="0" marL="0">
+              <a:buNone/>
+            </a:pPr>
+            <a:r>
+              <a:rPr lang="en-US" sz="4400" b="1" dirty="0">
+                <a:solidFill>
+                  <a:schemeClr val="accent2"/>
+                </a:solidFill>
+                <a:latin typeface="Arial" pitchFamily="34" charset="0"/>
+                <a:ea typeface="Arial" pitchFamily="34" charset="-122"/>
+                <a:cs typeface="Arial" pitchFamily="34" charset="-120"/>
+              </a:rPr>
+              <a:t>−78 °C</a:t>
+            </a:r>
+            <a:endParaRPr lang="en-US" sz="4400" dirty="0"/>
+          </a:p>
+        </p:txBody>
+      </p:sp>
+      <p:sp>
+        <p:nvSpPr>
+          <p:cNvPr id="8" name="stat label 1"/>
+          <p:cNvSpPr txBox="1"/>
+          <p:nvPr/>
+        </p:nvSpPr>
+        <p:spPr>
+          <a:xfrm>
+            <a:off x="4594860" y="2514600"/>
+            <a:ext cx="3017520" cy="685800"/>
+          </a:xfrm>
+          <a:prstGeom prst="rect">
+            <a:avLst/>
+          </a:prstGeom>
+          <a:noFill/>
+          <a:ln/>
+        </p:spPr>
+        <p:txBody>
+          <a:bodyPr wrap="square" lIns="0" tIns="0" rIns="0" bIns="0" rtlCol="0" anchor="t"/>
+          <a:lstStyle/>
+          <a:p>
+            <a:pPr indent="0" marL="0">
+              <a:buNone/>
+            </a:pPr>
+            <a:r>
+              <a:rPr lang="en-US" sz="1400" dirty="0">
+                <a:solidFill>
+                  <a:schemeClr val="tx2"/>
+                </a:solidFill>
+              </a:rPr>
+              <a:t>oxid uhličitý: po vystříknutí se mění na „sníh“</a:t>
+            </a:r>
+            <a:endParaRPr lang="en-US" sz="1400" dirty="0"/>
+          </a:p>
+        </p:txBody>
+      </p:sp>
+      <p:sp>
+        <p:nvSpPr>
+          <p:cNvPr id="9" name="stat 2"/>
+          <p:cNvSpPr/>
+          <p:nvPr/>
+        </p:nvSpPr>
+        <p:spPr>
+          <a:xfrm>
+            <a:off x="8092440" y="1463040"/>
+            <a:ext cx="3520440" cy="1828800"/>
+          </a:xfrm>
+          <a:prstGeom prst="roundRect">
+            <a:avLst>
+              <a:gd name="adj" fmla="val 6000"/>
+            </a:avLst>
+          </a:prstGeom>
+          <a:solidFill>
+            <a:schemeClr val="bg2"/>
+          </a:solidFill>
+          <a:ln/>
+        </p:spPr>
+      </p:sp>
+      <p:sp>
+        <p:nvSpPr>
+          <p:cNvPr id="10" name="stat value 2"/>
+          <p:cNvSpPr txBox="1"/>
+          <p:nvPr/>
+        </p:nvSpPr>
+        <p:spPr>
+          <a:xfrm>
+            <a:off x="8366760" y="1600200"/>
+            <a:ext cx="3017520" cy="868680"/>
+          </a:xfrm>
+          <a:prstGeom prst="rect">
+            <a:avLst/>
+          </a:prstGeom>
+          <a:noFill/>
+          <a:ln/>
+        </p:spPr>
+        <p:txBody>
+          <a:bodyPr wrap="square" lIns="0" tIns="0" rIns="0" bIns="0" rtlCol="0" anchor="t"/>
+          <a:lstStyle/>
+          <a:p>
+            <a:pPr indent="0" marL="0">
+              <a:buNone/>
+            </a:pPr>
+            <a:r>
+              <a:rPr lang="en-US" sz="4400" b="1" dirty="0">
+                <a:solidFill>
+                  <a:schemeClr val="accent1"/>
+                </a:solidFill>
+                <a:latin typeface="Arial" pitchFamily="34" charset="0"/>
+                <a:ea typeface="Arial" pitchFamily="34" charset="-122"/>
+                <a:cs typeface="Arial" pitchFamily="34" charset="-120"/>
+              </a:rPr>
+              <a:t>až 2–3×</a:t>
+            </a:r>
+            <a:endParaRPr lang="en-US" sz="4400" dirty="0"/>
+          </a:p>
+        </p:txBody>
+      </p:sp>
+      <p:sp>
+        <p:nvSpPr>
+          <p:cNvPr id="11" name="stat label 2"/>
+          <p:cNvSpPr txBox="1"/>
+          <p:nvPr/>
+        </p:nvSpPr>
+        <p:spPr>
+          <a:xfrm>
+            <a:off x="8366760" y="2514600"/>
+            <a:ext cx="3017520" cy="685800"/>
+          </a:xfrm>
+          <a:prstGeom prst="rect">
+            <a:avLst/>
+          </a:prstGeom>
+          <a:noFill/>
+          <a:ln/>
+        </p:spPr>
+        <p:txBody>
+          <a:bodyPr wrap="square" lIns="0" tIns="0" rIns="0" bIns="0" rtlCol="0" anchor="t"/>
+          <a:lstStyle/>
+          <a:p>
+            <a:pPr indent="0" marL="0">
+              <a:buNone/>
+            </a:pPr>
+            <a:r>
+              <a:rPr lang="en-US" sz="1400" dirty="0">
+                <a:solidFill>
+                  <a:schemeClr val="tx2"/>
+                </a:solidFill>
+              </a:rPr>
+              <a:t>delší životnost nástroje v nejlepších studiích (běžně desítky %)</a:t>
+            </a:r>
+            <a:endParaRPr lang="en-US" sz="1400" dirty="0"/>
+          </a:p>
+        </p:txBody>
+      </p:sp>
+      <p:sp>
+        <p:nvSpPr>
+          <p:cNvPr id="12" name="pros icon circle"/>
+          <p:cNvSpPr/>
+          <p:nvPr/>
+        </p:nvSpPr>
+        <p:spPr>
+          <a:xfrm>
+            <a:off x="548640" y="3657600"/>
+            <a:ext cx="502920" cy="502920"/>
           </a:xfrm>
           <a:prstGeom prst="ellipse">
             <a:avLst/>
           </a:prstGeom>
           <a:solidFill>
-            <a:schemeClr val="accent1"/>
+            <a:schemeClr val="accent2"/>
           </a:solidFill>
           <a:ln/>
         </p:spPr>
       </p:sp>
       <p:pic>
         <p:nvPicPr>
-          <p:cNvPr id="5" name="step icon 0" descr="step icon 0">    </p:cNvPr>
+          <p:cNvPr id="13" name="pros icon" descr="pros icon">    </p:cNvPr>
           <p:cNvPicPr>
             <a:picLocks noChangeAspect="1"/>
           </p:cNvPicPr>
@@ -4130,8 +5031,8 @@
         </p:blipFill>
         <p:spPr>
           <a:xfrm>
-            <a:off x="983894" y="1852574"/>
-            <a:ext cx="409651" cy="409651"/>
+            <a:off x="659282" y="3768242"/>
+            <a:ext cx="281635" cy="281635"/>
           </a:xfrm>
           <a:prstGeom prst="rect">
             <a:avLst/>
@@ -4140,14 +5041,14 @@
       </p:pic>
       <p:sp>
         <p:nvSpPr>
-          <p:cNvPr id="6" name="step title 0"/>
-          <p:cNvSpPr txBox="1"/>
-          <p:nvPr/>
-        </p:nvSpPr>
-        <p:spPr>
-          <a:xfrm>
-            <a:off x="1737360" y="1691640"/>
-            <a:ext cx="2011680" cy="731520"/>
+          <p:cNvPr id="14" name="pros title"/>
+          <p:cNvSpPr txBox="1"/>
+          <p:nvPr/>
+        </p:nvSpPr>
+        <p:spPr>
+          <a:xfrm>
+            <a:off x="1188720" y="3657600"/>
+            <a:ext cx="3657600" cy="502920"/>
           </a:xfrm>
           <a:prstGeom prst="rect">
             <a:avLst/>
@@ -4168,7 +5069,7 @@
                   <a:schemeClr val="tx1"/>
                 </a:solidFill>
               </a:rPr>
-              <a:t>Natisknout</a:t>
+              <a:t>Výhody</a:t>
             </a:r>
             <a:endParaRPr lang="en-US" sz="2000" dirty="0"/>
           </a:p>
@@ -4176,14 +5077,14 @@
       </p:sp>
       <p:sp>
         <p:nvSpPr>
-          <p:cNvPr id="7" name="step body 0"/>
-          <p:cNvSpPr txBox="1"/>
-          <p:nvPr/>
-        </p:nvSpPr>
-        <p:spPr>
-          <a:xfrm>
-            <a:off x="822960" y="2560320"/>
-            <a:ext cx="2880360" cy="868680"/>
+          <p:cNvPr id="15" name="pros list"/>
+          <p:cNvSpPr txBox="1"/>
+          <p:nvPr/>
+        </p:nvSpPr>
+        <p:spPr>
+          <a:xfrm>
+            <a:off x="548640" y="4343400"/>
+            <a:ext cx="5394960" cy="1737360"/>
           </a:xfrm>
           <a:prstGeom prst="rect">
             <a:avLst/>
@@ -4195,24 +5096,84 @@
           <a:bodyPr wrap="square" lIns="0" tIns="0" rIns="0" bIns="0" rtlCol="0" anchor="t"/>
           <a:lstStyle/>
           <a:p>
-            <a:pPr indent="0" marL="0">
-              <a:buNone/>
-            </a:pPr>
-            <a:r>
-              <a:rPr lang="en-US" sz="1400" dirty="0">
+            <a:pPr marL="228600" indent="-228600">
+              <a:spcAft>
+                <a:spcPts val="800"/>
+              </a:spcAft>
+              <a:buSzPct val="100000"/>
+              <a:buChar char="•"/>
+            </a:pPr>
+            <a:r>
+              <a:rPr lang="en-US" sz="1500" dirty="0">
                 <a:solidFill>
                   <a:schemeClr val="tx2"/>
                 </a:solidFill>
               </a:rPr>
-              <a:t>Laser taví kovový prášek a vrstvu po vrstvě staví hrubý tvar (DED)</a:t>
-            </a:r>
-            <a:endParaRPr lang="en-US" sz="1400" dirty="0"/>
-          </a:p>
-        </p:txBody>
+              <a:t>Odvádí teplo přímo z místa řezu</a:t>
+            </a:r>
+            <a:endParaRPr lang="en-US" sz="1500" dirty="0"/>
+          </a:p>
+          <a:p>
+            <a:pPr marL="228600" indent="-228600">
+              <a:spcAft>
+                <a:spcPts val="800"/>
+              </a:spcAft>
+              <a:buSzPct val="100000"/>
+              <a:buChar char="•"/>
+            </a:pPr>
+            <a:r>
+              <a:rPr lang="en-US" sz="1500" dirty="0">
+                <a:solidFill>
+                  <a:schemeClr val="tx2"/>
+                </a:solidFill>
+              </a:rPr>
+              <a:t>Žádná odpadní emulze, čisté třísky i obrobek</a:t>
+            </a:r>
+            <a:endParaRPr lang="en-US" sz="1500" dirty="0"/>
+          </a:p>
+          <a:p>
+            <a:pPr marL="228600" indent="-228600">
+              <a:spcAft>
+                <a:spcPts val="800"/>
+              </a:spcAft>
+              <a:buSzPct val="100000"/>
+              <a:buChar char="•"/>
+            </a:pPr>
+            <a:r>
+              <a:rPr lang="en-US" sz="1500" dirty="0">
+                <a:solidFill>
+                  <a:schemeClr val="tx2"/>
+                </a:solidFill>
+              </a:rPr>
+              <a:t>Ideální pro titan a Inconel (letectví, medicína)</a:t>
+            </a:r>
+            <a:endParaRPr lang="en-US" sz="1500" dirty="0"/>
+          </a:p>
+        </p:txBody>
+      </p:sp>
+      <p:sp>
+        <p:nvSpPr>
+          <p:cNvPr id="16" name="cons icon circle"/>
+          <p:cNvSpPr/>
+          <p:nvPr/>
+        </p:nvSpPr>
+        <p:spPr>
+          <a:xfrm>
+            <a:off x="6217920" y="3657600"/>
+            <a:ext cx="502920" cy="502920"/>
+          </a:xfrm>
+          <a:prstGeom prst="ellipse">
+            <a:avLst/>
+          </a:prstGeom>
+          <a:solidFill>
+            <a:schemeClr val="accent5"/>
+          </a:solidFill>
+          <a:ln/>
+        </p:spPr>
       </p:sp>
       <p:pic>
         <p:nvPicPr>
-          <p:cNvPr id="8" name="arrow 0" descr="šipka">    </p:cNvPr>
+          <p:cNvPr id="17" name="cons icon" descr="cons icon">    </p:cNvPr>
           <p:cNvPicPr>
             <a:picLocks noChangeAspect="1"/>
           </p:cNvPicPr>
@@ -4226,8 +5187,8 @@
         </p:blipFill>
         <p:spPr>
           <a:xfrm>
-            <a:off x="4005072" y="2267712"/>
-            <a:ext cx="384048" cy="384048"/>
+            <a:off x="6328562" y="3768242"/>
+            <a:ext cx="281635" cy="281635"/>
           </a:xfrm>
           <a:prstGeom prst="rect">
             <a:avLst/>
@@ -4236,80 +5197,14 @@
       </p:pic>
       <p:sp>
         <p:nvSpPr>
-          <p:cNvPr id="9" name="step 1"/>
-          <p:cNvSpPr/>
-          <p:nvPr/>
-        </p:nvSpPr>
-        <p:spPr>
-          <a:xfrm>
-            <a:off x="4389120" y="1463040"/>
-            <a:ext cx="3383280" cy="2011680"/>
-          </a:xfrm>
-          <a:prstGeom prst="roundRect">
-            <a:avLst>
-              <a:gd name="adj" fmla="val 5455"/>
-            </a:avLst>
-          </a:prstGeom>
-          <a:solidFill>
-            <a:schemeClr val="bg2"/>
-          </a:solidFill>
-          <a:ln/>
-        </p:spPr>
-      </p:sp>
-      <p:sp>
-        <p:nvSpPr>
-          <p:cNvPr id="10" name="step icon 1 circle"/>
-          <p:cNvSpPr/>
-          <p:nvPr/>
-        </p:nvSpPr>
-        <p:spPr>
-          <a:xfrm>
-            <a:off x="4663440" y="1691640"/>
-            <a:ext cx="731520" cy="731520"/>
-          </a:xfrm>
-          <a:prstGeom prst="ellipse">
-            <a:avLst/>
-          </a:prstGeom>
-          <a:solidFill>
-            <a:schemeClr val="accent1"/>
-          </a:solidFill>
-          <a:ln/>
-        </p:spPr>
-      </p:sp>
-      <p:pic>
-        <p:nvPicPr>
-          <p:cNvPr id="11" name="step icon 1" descr="step icon 1">    </p:cNvPr>
-          <p:cNvPicPr>
-            <a:picLocks noChangeAspect="1"/>
-          </p:cNvPicPr>
-          <p:nvPr/>
-        </p:nvPicPr>
-        <p:blipFill>
-          <a:blip r:embed="rId3"/>
-          <a:stretch>
-            <a:fillRect/>
-          </a:stretch>
-        </p:blipFill>
-        <p:spPr>
-          <a:xfrm>
-            <a:off x="4824374" y="1852574"/>
-            <a:ext cx="409651" cy="409651"/>
-          </a:xfrm>
-          <a:prstGeom prst="rect">
-            <a:avLst/>
-          </a:prstGeom>
-        </p:spPr>
-      </p:pic>
-      <p:sp>
-        <p:nvSpPr>
-          <p:cNvPr id="12" name="step title 1"/>
-          <p:cNvSpPr txBox="1"/>
-          <p:nvPr/>
-        </p:nvSpPr>
-        <p:spPr>
-          <a:xfrm>
-            <a:off x="5577840" y="1691640"/>
-            <a:ext cx="2011680" cy="731520"/>
+          <p:cNvPr id="18" name="cons title"/>
+          <p:cNvSpPr txBox="1"/>
+          <p:nvPr/>
+        </p:nvSpPr>
+        <p:spPr>
+          <a:xfrm>
+            <a:off x="6858000" y="3657600"/>
+            <a:ext cx="3657600" cy="502920"/>
           </a:xfrm>
           <a:prstGeom prst="rect">
             <a:avLst/>
@@ -4330,7 +5225,7 @@
                   <a:schemeClr val="tx1"/>
                 </a:solidFill>
               </a:rPr>
-              <a:t>Obrobit</a:t>
+              <a:t>Nevýhody</a:t>
             </a:r>
             <a:endParaRPr lang="en-US" sz="2000" dirty="0"/>
           </a:p>
@@ -4338,248 +5233,14 @@
       </p:sp>
       <p:sp>
         <p:nvSpPr>
-          <p:cNvPr id="13" name="step body 1"/>
-          <p:cNvSpPr txBox="1"/>
-          <p:nvPr/>
-        </p:nvSpPr>
-        <p:spPr>
-          <a:xfrm>
-            <a:off x="4663440" y="2560320"/>
-            <a:ext cx="2880360" cy="868680"/>
-          </a:xfrm>
-          <a:prstGeom prst="rect">
-            <a:avLst/>
-          </a:prstGeom>
-          <a:noFill/>
-          <a:ln/>
-        </p:spPr>
-        <p:txBody>
-          <a:bodyPr wrap="square" lIns="0" tIns="0" rIns="0" bIns="0" rtlCol="0" anchor="t"/>
-          <a:lstStyle/>
-          <a:p>
-            <a:pPr indent="0" marL="0">
-              <a:buNone/>
-            </a:pPr>
-            <a:r>
-              <a:rPr lang="en-US" sz="1400" dirty="0">
-                <a:solidFill>
-                  <a:schemeClr val="tx2"/>
-                </a:solidFill>
-              </a:rPr>
-              <a:t>Soustružnické a frézovací vřeteno dorobí díl na přesný rozměr</a:t>
-            </a:r>
-            <a:endParaRPr lang="en-US" sz="1400" dirty="0"/>
-          </a:p>
-        </p:txBody>
-      </p:sp>
-      <p:pic>
-        <p:nvPicPr>
-          <p:cNvPr id="14" name="arrow 1" descr="šipka">    </p:cNvPr>
-          <p:cNvPicPr>
-            <a:picLocks noChangeAspect="1"/>
-          </p:cNvPicPr>
-          <p:nvPr/>
-        </p:nvPicPr>
-        <p:blipFill>
-          <a:blip r:embed="rId4"/>
-          <a:stretch>
-            <a:fillRect/>
-          </a:stretch>
-        </p:blipFill>
-        <p:spPr>
-          <a:xfrm>
-            <a:off x="7845552" y="2267712"/>
-            <a:ext cx="384048" cy="384048"/>
-          </a:xfrm>
-          <a:prstGeom prst="rect">
-            <a:avLst/>
-          </a:prstGeom>
-        </p:spPr>
-      </p:pic>
-      <p:sp>
-        <p:nvSpPr>
-          <p:cNvPr id="15" name="step 2"/>
-          <p:cNvSpPr/>
-          <p:nvPr/>
-        </p:nvSpPr>
-        <p:spPr>
-          <a:xfrm>
-            <a:off x="8229600" y="1463040"/>
-            <a:ext cx="3383280" cy="2011680"/>
-          </a:xfrm>
-          <a:prstGeom prst="roundRect">
-            <a:avLst>
-              <a:gd name="adj" fmla="val 5455"/>
-            </a:avLst>
-          </a:prstGeom>
-          <a:solidFill>
-            <a:schemeClr val="bg2"/>
-          </a:solidFill>
-          <a:ln/>
-        </p:spPr>
-      </p:sp>
-      <p:sp>
-        <p:nvSpPr>
-          <p:cNvPr id="16" name="step icon 2 circle"/>
-          <p:cNvSpPr/>
-          <p:nvPr/>
-        </p:nvSpPr>
-        <p:spPr>
-          <a:xfrm>
-            <a:off x="8503920" y="1691640"/>
-            <a:ext cx="731520" cy="731520"/>
-          </a:xfrm>
-          <a:prstGeom prst="ellipse">
-            <a:avLst/>
-          </a:prstGeom>
-          <a:solidFill>
-            <a:schemeClr val="accent1"/>
-          </a:solidFill>
-          <a:ln/>
-        </p:spPr>
-      </p:sp>
-      <p:pic>
-        <p:nvPicPr>
-          <p:cNvPr id="17" name="step icon 2" descr="step icon 2">    </p:cNvPr>
-          <p:cNvPicPr>
-            <a:picLocks noChangeAspect="1"/>
-          </p:cNvPicPr>
-          <p:nvPr/>
-        </p:nvPicPr>
-        <p:blipFill>
-          <a:blip r:embed="rId5"/>
-          <a:stretch>
-            <a:fillRect/>
-          </a:stretch>
-        </p:blipFill>
-        <p:spPr>
-          <a:xfrm>
-            <a:off x="8664854" y="1852574"/>
-            <a:ext cx="409651" cy="409651"/>
-          </a:xfrm>
-          <a:prstGeom prst="rect">
-            <a:avLst/>
-          </a:prstGeom>
-        </p:spPr>
-      </p:pic>
-      <p:sp>
-        <p:nvSpPr>
-          <p:cNvPr id="18" name="step title 2"/>
-          <p:cNvSpPr txBox="1"/>
-          <p:nvPr/>
-        </p:nvSpPr>
-        <p:spPr>
-          <a:xfrm>
-            <a:off x="9418320" y="1691640"/>
-            <a:ext cx="2011680" cy="731520"/>
-          </a:xfrm>
-          <a:prstGeom prst="rect">
-            <a:avLst/>
-          </a:prstGeom>
-          <a:noFill/>
-          <a:ln/>
-        </p:spPr>
-        <p:txBody>
-          <a:bodyPr wrap="square" lIns="0" tIns="0" rIns="0" bIns="0" rtlCol="0" anchor="ctr"/>
-          <a:lstStyle/>
-          <a:p>
-            <a:pPr indent="0" marL="0">
-              <a:buNone/>
-            </a:pPr>
-            <a:r>
-              <a:rPr lang="en-US" sz="2000" b="1" dirty="0">
-                <a:solidFill>
-                  <a:schemeClr val="tx1"/>
-                </a:solidFill>
-              </a:rPr>
-              <a:t>Hotovo</a:t>
-            </a:r>
-            <a:endParaRPr lang="en-US" sz="2000" dirty="0"/>
-          </a:p>
-        </p:txBody>
-      </p:sp>
-      <p:sp>
-        <p:nvSpPr>
-          <p:cNvPr id="19" name="step body 2"/>
-          <p:cNvSpPr txBox="1"/>
-          <p:nvPr/>
-        </p:nvSpPr>
-        <p:spPr>
-          <a:xfrm>
-            <a:off x="8503920" y="2560320"/>
-            <a:ext cx="2880360" cy="868680"/>
-          </a:xfrm>
-          <a:prstGeom prst="rect">
-            <a:avLst/>
-          </a:prstGeom>
-          <a:noFill/>
-          <a:ln/>
-        </p:spPr>
-        <p:txBody>
-          <a:bodyPr wrap="square" lIns="0" tIns="0" rIns="0" bIns="0" rtlCol="0" anchor="t"/>
-          <a:lstStyle/>
-          <a:p>
-            <a:pPr indent="0" marL="0">
-              <a:buNone/>
-            </a:pPr>
-            <a:r>
-              <a:rPr lang="en-US" sz="1400" dirty="0">
-                <a:solidFill>
-                  <a:schemeClr val="tx2"/>
-                </a:solidFill>
-              </a:rPr>
-              <a:t>Vše na jedno upnutí, bez přenášení mezi stroji</a:t>
-            </a:r>
-            <a:endParaRPr lang="en-US" sz="1400" dirty="0"/>
-          </a:p>
-        </p:txBody>
-      </p:sp>
-      <p:sp>
-        <p:nvSpPr>
-          <p:cNvPr id="20" name="why title"/>
-          <p:cNvSpPr txBox="1"/>
-          <p:nvPr/>
-        </p:nvSpPr>
-        <p:spPr>
-          <a:xfrm>
-            <a:off x="548640" y="3840480"/>
-            <a:ext cx="6400800" cy="457200"/>
-          </a:xfrm>
-          <a:prstGeom prst="rect">
-            <a:avLst/>
-          </a:prstGeom>
-          <a:noFill/>
-          <a:ln/>
-        </p:spPr>
-        <p:txBody>
-          <a:bodyPr wrap="square" lIns="0" tIns="0" rIns="0" bIns="0" rtlCol="0" anchor="t"/>
-          <a:lstStyle/>
-          <a:p>
-            <a:pPr indent="0" marL="0">
-              <a:buNone/>
-            </a:pPr>
-            <a:r>
-              <a:rPr lang="en-US" sz="2000" b="1" dirty="0">
-                <a:solidFill>
-                  <a:schemeClr val="tx1"/>
-                </a:solidFill>
-              </a:rPr>
-              <a:t>Proč je to užitečné</a:t>
-            </a:r>
-            <a:endParaRPr lang="en-US" sz="2000" dirty="0"/>
-          </a:p>
-        </p:txBody>
-      </p:sp>
-      <p:sp>
-        <p:nvSpPr>
-          <p:cNvPr id="21" name="why list"/>
-          <p:cNvSpPr txBox="1"/>
-          <p:nvPr/>
-        </p:nvSpPr>
-        <p:spPr>
-          <a:xfrm>
-            <a:off x="548640" y="4389120"/>
-            <a:ext cx="6675120" cy="1737360"/>
+          <p:cNvPr id="19" name="cons list"/>
+          <p:cNvSpPr txBox="1"/>
+          <p:nvPr/>
+        </p:nvSpPr>
+        <p:spPr>
+          <a:xfrm>
+            <a:off x="6217920" y="4343400"/>
+            <a:ext cx="5394960" cy="1737360"/>
           </a:xfrm>
           <a:prstGeom prst="rect">
             <a:avLst/>
@@ -4604,7 +5265,7 @@
                   <a:schemeClr val="tx2"/>
                 </a:solidFill>
               </a:rPr>
-              <a:t>Vyšší přesnost: díl se mezi kroky nepřepíná</a:t>
+              <a:t>Výroba tekutého dusíku spotřebuje hodně energie</a:t>
             </a:r>
             <a:endParaRPr lang="en-US" sz="1500" dirty="0"/>
           </a:p>
@@ -4622,7 +5283,7 @@
                   <a:schemeClr val="tx2"/>
                 </a:solidFill>
               </a:rPr>
-              <a:t>Méně odpadu: materiál se přidává jen tam, kde je potřeba</a:t>
+              <a:t>Drahé zařízení, izolované rozvody</a:t>
             </a:r>
             <a:endParaRPr lang="en-US" sz="1500" dirty="0"/>
           </a:p>
@@ -4640,141 +5301,7 @@
                   <a:schemeClr val="tx2"/>
                 </a:solidFill>
               </a:rPr>
-              <a:t>Opravy drahých dílů: navaření a obrobení opotřebené lopatky turbíny</a:t>
-            </a:r>
-            <a:endParaRPr lang="en-US" sz="1500" dirty="0"/>
-          </a:p>
-        </p:txBody>
-      </p:sp>
-      <p:sp>
-        <p:nvSpPr>
-          <p:cNvPr id="22" name="examples card"/>
-          <p:cNvSpPr/>
-          <p:nvPr/>
-        </p:nvSpPr>
-        <p:spPr>
-          <a:xfrm>
-            <a:off x="7589520" y="3840480"/>
-            <a:ext cx="4023360" cy="2194560"/>
-          </a:xfrm>
-          <a:prstGeom prst="roundRect">
-            <a:avLst>
-              <a:gd name="adj" fmla="val 5000"/>
-            </a:avLst>
-          </a:prstGeom>
-          <a:solidFill>
-            <a:schemeClr val="tx1"/>
-          </a:solidFill>
-          <a:ln/>
-        </p:spPr>
-      </p:sp>
-      <p:sp>
-        <p:nvSpPr>
-          <p:cNvPr id="23" name="ex title"/>
-          <p:cNvSpPr txBox="1"/>
-          <p:nvPr/>
-        </p:nvSpPr>
-        <p:spPr>
-          <a:xfrm>
-            <a:off x="7863840" y="4023360"/>
-            <a:ext cx="3566160" cy="411480"/>
-          </a:xfrm>
-          <a:prstGeom prst="rect">
-            <a:avLst/>
-          </a:prstGeom>
-          <a:noFill/>
-          <a:ln/>
-        </p:spPr>
-        <p:txBody>
-          <a:bodyPr wrap="square" lIns="0" tIns="0" rIns="0" bIns="0" rtlCol="0" anchor="t"/>
-          <a:lstStyle/>
-          <a:p>
-            <a:pPr indent="0" marL="0">
-              <a:buNone/>
-            </a:pPr>
-            <a:r>
-              <a:rPr lang="en-US" sz="1800" b="1" dirty="0">
-                <a:solidFill>
-                  <a:schemeClr val="accent1"/>
-                </a:solidFill>
-              </a:rPr>
-              <a:t>Příklady strojů</a:t>
-            </a:r>
-            <a:endParaRPr lang="en-US" sz="1800" dirty="0"/>
-          </a:p>
-        </p:txBody>
-      </p:sp>
-      <p:sp>
-        <p:nvSpPr>
-          <p:cNvPr id="24" name="ex list"/>
-          <p:cNvSpPr txBox="1"/>
-          <p:nvPr/>
-        </p:nvSpPr>
-        <p:spPr>
-          <a:xfrm>
-            <a:off x="7863840" y="4526280"/>
-            <a:ext cx="3566160" cy="1371600"/>
-          </a:xfrm>
-          <a:prstGeom prst="rect">
-            <a:avLst/>
-          </a:prstGeom>
-          <a:noFill/>
-          <a:ln/>
-        </p:spPr>
-        <p:txBody>
-          <a:bodyPr wrap="square" lIns="0" tIns="0" rIns="0" bIns="0" rtlCol="0" anchor="t"/>
-          <a:lstStyle/>
-          <a:p>
-            <a:pPr marL="228600" indent="-228600">
-              <a:spcAft>
-                <a:spcPts val="600"/>
-              </a:spcAft>
-              <a:buSzPct val="100000"/>
-              <a:buChar char="•"/>
-            </a:pPr>
-            <a:r>
-              <a:rPr lang="en-US" sz="1500" dirty="0">
-                <a:solidFill>
-                  <a:schemeClr val="bg1"/>
-                </a:solidFill>
-              </a:rPr>
-              <a:t>Okuma LASER EX</a:t>
-            </a:r>
-            <a:endParaRPr lang="en-US" sz="1500" dirty="0"/>
-          </a:p>
-          <a:p>
-            <a:pPr marL="228600" indent="-228600">
-              <a:spcAft>
-                <a:spcPts val="600"/>
-              </a:spcAft>
-              <a:buSzPct val="100000"/>
-              <a:buChar char="•"/>
-            </a:pPr>
-            <a:r>
-              <a:rPr lang="en-US" sz="1500" dirty="0">
-                <a:solidFill>
-                  <a:schemeClr val="bg1"/>
-                </a:solidFill>
-              </a:rPr>
-              <a:t>DMG MORI LASERTEC DED hybrid</a:t>
-            </a:r>
-            <a:endParaRPr lang="en-US" sz="1500" dirty="0"/>
-          </a:p>
-          <a:p>
-            <a:pPr marL="228600" indent="-228600">
-              <a:spcAft>
-                <a:spcPts val="600"/>
-              </a:spcAft>
-              <a:buSzPct val="100000"/>
-              <a:buChar char="•"/>
-            </a:pPr>
-            <a:r>
-              <a:rPr lang="en-US" sz="1500" dirty="0">
-                <a:solidFill>
-                  <a:schemeClr val="bg1"/>
-                </a:solidFill>
-              </a:rPr>
-              <a:t>Mazak INTEGREX i-AM</a:t>
+              <a:t>Dusík nemaže, proto se často kombinuje s mikromazáním (MQL)</a:t>
             </a:r>
             <a:endParaRPr lang="en-US" sz="1500" dirty="0"/>
           </a:p>
@@ -4882,7 +5409,7 @@
                   <a:schemeClr val="tx1"/>
                 </a:solidFill>
               </a:rPr>
-              <a:t>2 · Kryogenní obrábění: chlazení tekutým dusíkem</a:t>
+              <a:t>3 · Laserem asistované soustružení</a:t>
             </a:r>
             <a:endParaRPr lang="en-US" sz="3400" dirty="0"/>
           </a:p>
@@ -4890,318 +5417,27 @@
       </p:sp>
       <p:sp>
         <p:nvSpPr>
-          <p:cNvPr id="3" name="stat 0"/>
+          <p:cNvPr id="3" name="lam icon 0 circle"/>
           <p:cNvSpPr/>
           <p:nvPr/>
         </p:nvSpPr>
         <p:spPr>
           <a:xfrm>
-            <a:off x="548640" y="1463040"/>
-            <a:ext cx="3520440" cy="1828800"/>
-          </a:xfrm>
-          <a:prstGeom prst="roundRect">
-            <a:avLst>
-              <a:gd name="adj" fmla="val 6000"/>
-            </a:avLst>
+            <a:off x="1645920" y="1463040"/>
+            <a:ext cx="1097280" cy="1097280"/>
+          </a:xfrm>
+          <a:prstGeom prst="ellipse">
+            <a:avLst/>
           </a:prstGeom>
           <a:solidFill>
-            <a:schemeClr val="bg2"/>
-          </a:solidFill>
-          <a:ln/>
-        </p:spPr>
-      </p:sp>
-      <p:sp>
-        <p:nvSpPr>
-          <p:cNvPr id="4" name="stat value 0"/>
-          <p:cNvSpPr txBox="1"/>
-          <p:nvPr/>
-        </p:nvSpPr>
-        <p:spPr>
-          <a:xfrm>
-            <a:off x="822960" y="1600200"/>
-            <a:ext cx="3017520" cy="868680"/>
-          </a:xfrm>
-          <a:prstGeom prst="rect">
-            <a:avLst/>
-          </a:prstGeom>
-          <a:noFill/>
-          <a:ln/>
-        </p:spPr>
-        <p:txBody>
-          <a:bodyPr wrap="square" lIns="0" tIns="0" rIns="0" bIns="0" rtlCol="0" anchor="t"/>
-          <a:lstStyle/>
-          <a:p>
-            <a:pPr indent="0" marL="0">
-              <a:buNone/>
-            </a:pPr>
-            <a:r>
-              <a:rPr lang="en-US" sz="4400" b="1" dirty="0">
-                <a:solidFill>
-                  <a:schemeClr val="accent2"/>
-                </a:solidFill>
-                <a:latin typeface="Arial" pitchFamily="34" charset="0"/>
-                <a:ea typeface="Arial" pitchFamily="34" charset="-122"/>
-                <a:cs typeface="Arial" pitchFamily="34" charset="-120"/>
-              </a:rPr>
-              <a:t>−196 °C</a:t>
-            </a:r>
-            <a:endParaRPr lang="en-US" sz="4400" dirty="0"/>
-          </a:p>
-        </p:txBody>
-      </p:sp>
-      <p:sp>
-        <p:nvSpPr>
-          <p:cNvPr id="5" name="stat label 0"/>
-          <p:cNvSpPr txBox="1"/>
-          <p:nvPr/>
-        </p:nvSpPr>
-        <p:spPr>
-          <a:xfrm>
-            <a:off x="822960" y="2514600"/>
-            <a:ext cx="3017520" cy="685800"/>
-          </a:xfrm>
-          <a:prstGeom prst="rect">
-            <a:avLst/>
-          </a:prstGeom>
-          <a:noFill/>
-          <a:ln/>
-        </p:spPr>
-        <p:txBody>
-          <a:bodyPr wrap="square" lIns="0" tIns="0" rIns="0" bIns="0" rtlCol="0" anchor="t"/>
-          <a:lstStyle/>
-          <a:p>
-            <a:pPr indent="0" marL="0">
-              <a:buNone/>
-            </a:pPr>
-            <a:r>
-              <a:rPr lang="en-US" sz="1400" dirty="0">
-                <a:solidFill>
-                  <a:schemeClr val="tx2"/>
-                </a:solidFill>
-              </a:rPr>
-              <a:t>tekutý dusík (LN₂) stříkaný přímo na břit</a:t>
-            </a:r>
-            <a:endParaRPr lang="en-US" sz="1400" dirty="0"/>
-          </a:p>
-        </p:txBody>
-      </p:sp>
-      <p:sp>
-        <p:nvSpPr>
-          <p:cNvPr id="6" name="stat 1"/>
-          <p:cNvSpPr/>
-          <p:nvPr/>
-        </p:nvSpPr>
-        <p:spPr>
-          <a:xfrm>
-            <a:off x="4320540" y="1463040"/>
-            <a:ext cx="3520440" cy="1828800"/>
-          </a:xfrm>
-          <a:prstGeom prst="roundRect">
-            <a:avLst>
-              <a:gd name="adj" fmla="val 6000"/>
-            </a:avLst>
-          </a:prstGeom>
-          <a:solidFill>
-            <a:schemeClr val="bg2"/>
-          </a:solidFill>
-          <a:ln/>
-        </p:spPr>
-      </p:sp>
-      <p:sp>
-        <p:nvSpPr>
-          <p:cNvPr id="7" name="stat value 1"/>
-          <p:cNvSpPr txBox="1"/>
-          <p:nvPr/>
-        </p:nvSpPr>
-        <p:spPr>
-          <a:xfrm>
-            <a:off x="4594860" y="1600200"/>
-            <a:ext cx="3017520" cy="868680"/>
-          </a:xfrm>
-          <a:prstGeom prst="rect">
-            <a:avLst/>
-          </a:prstGeom>
-          <a:noFill/>
-          <a:ln/>
-        </p:spPr>
-        <p:txBody>
-          <a:bodyPr wrap="square" lIns="0" tIns="0" rIns="0" bIns="0" rtlCol="0" anchor="t"/>
-          <a:lstStyle/>
-          <a:p>
-            <a:pPr indent="0" marL="0">
-              <a:buNone/>
-            </a:pPr>
-            <a:r>
-              <a:rPr lang="en-US" sz="4400" b="1" dirty="0">
-                <a:solidFill>
-                  <a:schemeClr val="accent2"/>
-                </a:solidFill>
-                <a:latin typeface="Arial" pitchFamily="34" charset="0"/>
-                <a:ea typeface="Arial" pitchFamily="34" charset="-122"/>
-                <a:cs typeface="Arial" pitchFamily="34" charset="-120"/>
-              </a:rPr>
-              <a:t>−78 °C</a:t>
-            </a:r>
-            <a:endParaRPr lang="en-US" sz="4400" dirty="0"/>
-          </a:p>
-        </p:txBody>
-      </p:sp>
-      <p:sp>
-        <p:nvSpPr>
-          <p:cNvPr id="8" name="stat label 1"/>
-          <p:cNvSpPr txBox="1"/>
-          <p:nvPr/>
-        </p:nvSpPr>
-        <p:spPr>
-          <a:xfrm>
-            <a:off x="4594860" y="2514600"/>
-            <a:ext cx="3017520" cy="685800"/>
-          </a:xfrm>
-          <a:prstGeom prst="rect">
-            <a:avLst/>
-          </a:prstGeom>
-          <a:noFill/>
-          <a:ln/>
-        </p:spPr>
-        <p:txBody>
-          <a:bodyPr wrap="square" lIns="0" tIns="0" rIns="0" bIns="0" rtlCol="0" anchor="t"/>
-          <a:lstStyle/>
-          <a:p>
-            <a:pPr indent="0" marL="0">
-              <a:buNone/>
-            </a:pPr>
-            <a:r>
-              <a:rPr lang="en-US" sz="1400" dirty="0">
-                <a:solidFill>
-                  <a:schemeClr val="tx2"/>
-                </a:solidFill>
-              </a:rPr>
-              <a:t>oxid uhličitý: po vystříknutí se mění na „sníh“</a:t>
-            </a:r>
-            <a:endParaRPr lang="en-US" sz="1400" dirty="0"/>
-          </a:p>
-        </p:txBody>
-      </p:sp>
-      <p:sp>
-        <p:nvSpPr>
-          <p:cNvPr id="9" name="stat 2"/>
-          <p:cNvSpPr/>
-          <p:nvPr/>
-        </p:nvSpPr>
-        <p:spPr>
-          <a:xfrm>
-            <a:off x="8092440" y="1463040"/>
-            <a:ext cx="3520440" cy="1828800"/>
-          </a:xfrm>
-          <a:prstGeom prst="roundRect">
-            <a:avLst>
-              <a:gd name="adj" fmla="val 6000"/>
-            </a:avLst>
-          </a:prstGeom>
-          <a:solidFill>
-            <a:schemeClr val="bg2"/>
-          </a:solidFill>
-          <a:ln/>
-        </p:spPr>
-      </p:sp>
-      <p:sp>
-        <p:nvSpPr>
-          <p:cNvPr id="10" name="stat value 2"/>
-          <p:cNvSpPr txBox="1"/>
-          <p:nvPr/>
-        </p:nvSpPr>
-        <p:spPr>
-          <a:xfrm>
-            <a:off x="8366760" y="1600200"/>
-            <a:ext cx="3017520" cy="868680"/>
-          </a:xfrm>
-          <a:prstGeom prst="rect">
-            <a:avLst/>
-          </a:prstGeom>
-          <a:noFill/>
-          <a:ln/>
-        </p:spPr>
-        <p:txBody>
-          <a:bodyPr wrap="square" lIns="0" tIns="0" rIns="0" bIns="0" rtlCol="0" anchor="t"/>
-          <a:lstStyle/>
-          <a:p>
-            <a:pPr indent="0" marL="0">
-              <a:buNone/>
-            </a:pPr>
-            <a:r>
-              <a:rPr lang="en-US" sz="4400" b="1" dirty="0">
-                <a:solidFill>
-                  <a:schemeClr val="accent1"/>
-                </a:solidFill>
-                <a:latin typeface="Arial" pitchFamily="34" charset="0"/>
-                <a:ea typeface="Arial" pitchFamily="34" charset="-122"/>
-                <a:cs typeface="Arial" pitchFamily="34" charset="-120"/>
-              </a:rPr>
-              <a:t>až 2–3×</a:t>
-            </a:r>
-            <a:endParaRPr lang="en-US" sz="4400" dirty="0"/>
-          </a:p>
-        </p:txBody>
-      </p:sp>
-      <p:sp>
-        <p:nvSpPr>
-          <p:cNvPr id="11" name="stat label 2"/>
-          <p:cNvSpPr txBox="1"/>
-          <p:nvPr/>
-        </p:nvSpPr>
-        <p:spPr>
-          <a:xfrm>
-            <a:off x="8366760" y="2514600"/>
-            <a:ext cx="3017520" cy="685800"/>
-          </a:xfrm>
-          <a:prstGeom prst="rect">
-            <a:avLst/>
-          </a:prstGeom>
-          <a:noFill/>
-          <a:ln/>
-        </p:spPr>
-        <p:txBody>
-          <a:bodyPr wrap="square" lIns="0" tIns="0" rIns="0" bIns="0" rtlCol="0" anchor="t"/>
-          <a:lstStyle/>
-          <a:p>
-            <a:pPr indent="0" marL="0">
-              <a:buNone/>
-            </a:pPr>
-            <a:r>
-              <a:rPr lang="en-US" sz="1400" dirty="0">
-                <a:solidFill>
-                  <a:schemeClr val="tx2"/>
-                </a:solidFill>
-              </a:rPr>
-              <a:t>delší životnost nástroje v nejlepších studiích (běžně desítky %)</a:t>
-            </a:r>
-            <a:endParaRPr lang="en-US" sz="1400" dirty="0"/>
-          </a:p>
-        </p:txBody>
-      </p:sp>
-      <p:sp>
-        <p:nvSpPr>
-          <p:cNvPr id="12" name="pros icon circle"/>
-          <p:cNvSpPr/>
-          <p:nvPr/>
-        </p:nvSpPr>
-        <p:spPr>
-          <a:xfrm>
-            <a:off x="548640" y="3657600"/>
-            <a:ext cx="502920" cy="502920"/>
-          </a:xfrm>
-          <a:prstGeom prst="ellipse">
-            <a:avLst/>
-          </a:prstGeom>
-          <a:solidFill>
-            <a:schemeClr val="accent2"/>
+            <a:schemeClr val="accent1"/>
           </a:solidFill>
           <a:ln/>
         </p:spPr>
       </p:sp>
       <p:pic>
         <p:nvPicPr>
-          <p:cNvPr id="13" name="pros icon" descr="pros icon">    </p:cNvPr>
+          <p:cNvPr id="4" name="lam icon 0" descr="lam icon 0">    </p:cNvPr>
           <p:cNvPicPr>
             <a:picLocks noChangeAspect="1"/>
           </p:cNvPicPr>
@@ -5215,8 +5451,8 @@
         </p:blipFill>
         <p:spPr>
           <a:xfrm>
-            <a:off x="659282" y="3768242"/>
-            <a:ext cx="281635" cy="281635"/>
+            <a:off x="1887322" y="1704442"/>
+            <a:ext cx="614477" cy="614477"/>
           </a:xfrm>
           <a:prstGeom prst="rect">
             <a:avLst/>
@@ -5225,50 +5461,50 @@
       </p:pic>
       <p:sp>
         <p:nvSpPr>
-          <p:cNvPr id="14" name="pros title"/>
-          <p:cNvSpPr txBox="1"/>
-          <p:nvPr/>
-        </p:nvSpPr>
-        <p:spPr>
-          <a:xfrm>
-            <a:off x="1188720" y="3657600"/>
-            <a:ext cx="3657600" cy="502920"/>
-          </a:xfrm>
-          <a:prstGeom prst="rect">
-            <a:avLst/>
-          </a:prstGeom>
-          <a:noFill/>
-          <a:ln/>
-        </p:spPr>
-        <p:txBody>
-          <a:bodyPr wrap="square" lIns="0" tIns="0" rIns="0" bIns="0" rtlCol="0" anchor="ctr"/>
-          <a:lstStyle/>
-          <a:p>
-            <a:pPr indent="0" marL="0">
-              <a:buNone/>
-            </a:pPr>
-            <a:r>
-              <a:rPr lang="en-US" sz="2000" b="1" dirty="0">
+          <p:cNvPr id="5" name="lam title 0"/>
+          <p:cNvSpPr txBox="1"/>
+          <p:nvPr/>
+        </p:nvSpPr>
+        <p:spPr>
+          <a:xfrm>
+            <a:off x="548640" y="2697480"/>
+            <a:ext cx="3291840" cy="411480"/>
+          </a:xfrm>
+          <a:prstGeom prst="rect">
+            <a:avLst/>
+          </a:prstGeom>
+          <a:noFill/>
+          <a:ln/>
+        </p:spPr>
+        <p:txBody>
+          <a:bodyPr wrap="square" lIns="0" tIns="0" rIns="0" bIns="0" rtlCol="0" anchor="t"/>
+          <a:lstStyle/>
+          <a:p>
+            <a:pPr algn="ctr" indent="0" marL="0">
+              <a:buNone/>
+            </a:pPr>
+            <a:r>
+              <a:rPr lang="en-US" sz="1900" b="1" dirty="0">
                 <a:solidFill>
                   <a:schemeClr val="tx1"/>
                 </a:solidFill>
               </a:rPr>
-              <a:t>Výhody</a:t>
-            </a:r>
-            <a:endParaRPr lang="en-US" sz="2000" dirty="0"/>
-          </a:p>
-        </p:txBody>
-      </p:sp>
-      <p:sp>
-        <p:nvSpPr>
-          <p:cNvPr id="15" name="pros list"/>
-          <p:cNvSpPr txBox="1"/>
-          <p:nvPr/>
-        </p:nvSpPr>
-        <p:spPr>
-          <a:xfrm>
-            <a:off x="548640" y="4343400"/>
-            <a:ext cx="5394960" cy="1737360"/>
+              <a:t>Laser ohřeje</a:t>
+            </a:r>
+            <a:endParaRPr lang="en-US" sz="1900" dirty="0"/>
+          </a:p>
+        </p:txBody>
+      </p:sp>
+      <p:sp>
+        <p:nvSpPr>
+          <p:cNvPr id="6" name="lam body 0"/>
+          <p:cNvSpPr txBox="1"/>
+          <p:nvPr/>
+        </p:nvSpPr>
+        <p:spPr>
+          <a:xfrm>
+            <a:off x="548640" y="3108960"/>
+            <a:ext cx="3291840" cy="640080"/>
           </a:xfrm>
           <a:prstGeom prst="rect">
             <a:avLst/>
@@ -5280,12 +5516,8 @@
           <a:bodyPr wrap="square" lIns="0" tIns="0" rIns="0" bIns="0" rtlCol="0" anchor="t"/>
           <a:lstStyle/>
           <a:p>
-            <a:pPr marL="228600" indent="-228600">
-              <a:spcAft>
-                <a:spcPts val="800"/>
-              </a:spcAft>
-              <a:buSzPct val="100000"/>
-              <a:buChar char="•"/>
+            <a:pPr algn="ctr" indent="0" marL="0">
+              <a:buNone/>
             </a:pPr>
             <a:r>
               <a:rPr lang="en-US" sz="1500" dirty="0">
@@ -5293,71 +5525,15 @@
                   <a:schemeClr val="tx2"/>
                 </a:solidFill>
               </a:rPr>
-              <a:t>Odvádí teplo přímo z místa řezu</a:t>
+              <a:t>Paprsek míří na obrobek těsně před břit nože</a:t>
             </a:r>
             <a:endParaRPr lang="en-US" sz="1500" dirty="0"/>
           </a:p>
-          <a:p>
-            <a:pPr marL="228600" indent="-228600">
-              <a:spcAft>
-                <a:spcPts val="800"/>
-              </a:spcAft>
-              <a:buSzPct val="100000"/>
-              <a:buChar char="•"/>
-            </a:pPr>
-            <a:r>
-              <a:rPr lang="en-US" sz="1500" dirty="0">
-                <a:solidFill>
-                  <a:schemeClr val="tx2"/>
-                </a:solidFill>
-              </a:rPr>
-              <a:t>Žádná odpadní emulze, čisté třísky i obrobek</a:t>
-            </a:r>
-            <a:endParaRPr lang="en-US" sz="1500" dirty="0"/>
-          </a:p>
-          <a:p>
-            <a:pPr marL="228600" indent="-228600">
-              <a:spcAft>
-                <a:spcPts val="800"/>
-              </a:spcAft>
-              <a:buSzPct val="100000"/>
-              <a:buChar char="•"/>
-            </a:pPr>
-            <a:r>
-              <a:rPr lang="en-US" sz="1500" dirty="0">
-                <a:solidFill>
-                  <a:schemeClr val="tx2"/>
-                </a:solidFill>
-              </a:rPr>
-              <a:t>Ideální pro titan a Inconel (letectví, medicína)</a:t>
-            </a:r>
-            <a:endParaRPr lang="en-US" sz="1500" dirty="0"/>
-          </a:p>
-        </p:txBody>
-      </p:sp>
-      <p:sp>
-        <p:nvSpPr>
-          <p:cNvPr id="16" name="cons icon circle"/>
-          <p:cNvSpPr/>
-          <p:nvPr/>
-        </p:nvSpPr>
-        <p:spPr>
-          <a:xfrm>
-            <a:off x="6217920" y="3657600"/>
-            <a:ext cx="502920" cy="502920"/>
-          </a:xfrm>
-          <a:prstGeom prst="ellipse">
-            <a:avLst/>
-          </a:prstGeom>
-          <a:solidFill>
-            <a:schemeClr val="accent5"/>
-          </a:solidFill>
-          <a:ln/>
-        </p:spPr>
+        </p:txBody>
       </p:sp>
       <p:pic>
         <p:nvPicPr>
-          <p:cNvPr id="17" name="cons icon" descr="cons icon">    </p:cNvPr>
+          <p:cNvPr id="7" name="lam arrow 0" descr="šipka">    </p:cNvPr>
           <p:cNvPicPr>
             <a:picLocks noChangeAspect="1"/>
           </p:cNvPicPr>
@@ -5371,8 +5547,8 @@
         </p:blipFill>
         <p:spPr>
           <a:xfrm>
-            <a:off x="6328562" y="3768242"/>
-            <a:ext cx="281635" cy="281635"/>
+            <a:off x="3931920" y="1828800"/>
+            <a:ext cx="411480" cy="411480"/>
           </a:xfrm>
           <a:prstGeom prst="rect">
             <a:avLst/>
@@ -5381,50 +5557,328 @@
       </p:pic>
       <p:sp>
         <p:nvSpPr>
-          <p:cNvPr id="18" name="cons title"/>
-          <p:cNvSpPr txBox="1"/>
-          <p:nvPr/>
-        </p:nvSpPr>
-        <p:spPr>
-          <a:xfrm>
-            <a:off x="6858000" y="3657600"/>
-            <a:ext cx="3657600" cy="502920"/>
-          </a:xfrm>
-          <a:prstGeom prst="rect">
-            <a:avLst/>
-          </a:prstGeom>
-          <a:noFill/>
-          <a:ln/>
-        </p:spPr>
-        <p:txBody>
-          <a:bodyPr wrap="square" lIns="0" tIns="0" rIns="0" bIns="0" rtlCol="0" anchor="ctr"/>
+          <p:cNvPr id="8" name="lam icon 1 circle"/>
+          <p:cNvSpPr/>
+          <p:nvPr/>
+        </p:nvSpPr>
+        <p:spPr>
+          <a:xfrm>
+            <a:off x="5547665" y="1463040"/>
+            <a:ext cx="1097280" cy="1097280"/>
+          </a:xfrm>
+          <a:prstGeom prst="ellipse">
+            <a:avLst/>
+          </a:prstGeom>
+          <a:solidFill>
+            <a:schemeClr val="accent6"/>
+          </a:solidFill>
+          <a:ln/>
+        </p:spPr>
+      </p:sp>
+      <p:pic>
+        <p:nvPicPr>
+          <p:cNvPr id="9" name="lam icon 1" descr="lam icon 1">    </p:cNvPr>
+          <p:cNvPicPr>
+            <a:picLocks noChangeAspect="1"/>
+          </p:cNvPicPr>
+          <p:nvPr/>
+        </p:nvPicPr>
+        <p:blipFill>
+          <a:blip r:embed="rId3"/>
+          <a:stretch>
+            <a:fillRect/>
+          </a:stretch>
+        </p:blipFill>
+        <p:spPr>
+          <a:xfrm>
+            <a:off x="5789066" y="1704442"/>
+            <a:ext cx="614477" cy="614477"/>
+          </a:xfrm>
+          <a:prstGeom prst="rect">
+            <a:avLst/>
+          </a:prstGeom>
+        </p:spPr>
+      </p:pic>
+      <p:sp>
+        <p:nvSpPr>
+          <p:cNvPr id="10" name="lam title 1"/>
+          <p:cNvSpPr txBox="1"/>
+          <p:nvPr/>
+        </p:nvSpPr>
+        <p:spPr>
+          <a:xfrm>
+            <a:off x="4450385" y="2697480"/>
+            <a:ext cx="3291840" cy="411480"/>
+          </a:xfrm>
+          <a:prstGeom prst="rect">
+            <a:avLst/>
+          </a:prstGeom>
+          <a:noFill/>
+          <a:ln/>
+        </p:spPr>
+        <p:txBody>
+          <a:bodyPr wrap="square" lIns="0" tIns="0" rIns="0" bIns="0" rtlCol="0" anchor="t"/>
+          <a:lstStyle/>
+          <a:p>
+            <a:pPr algn="ctr" indent="0" marL="0">
+              <a:buNone/>
+            </a:pPr>
+            <a:r>
+              <a:rPr lang="en-US" sz="1900" b="1" dirty="0">
+                <a:solidFill>
+                  <a:schemeClr val="tx1"/>
+                </a:solidFill>
+              </a:rPr>
+              <a:t>Materiál změkne</a:t>
+            </a:r>
+            <a:endParaRPr lang="en-US" sz="1900" dirty="0"/>
+          </a:p>
+        </p:txBody>
+      </p:sp>
+      <p:sp>
+        <p:nvSpPr>
+          <p:cNvPr id="11" name="lam body 1"/>
+          <p:cNvSpPr txBox="1"/>
+          <p:nvPr/>
+        </p:nvSpPr>
+        <p:spPr>
+          <a:xfrm>
+            <a:off x="4450385" y="3108960"/>
+            <a:ext cx="3291840" cy="640080"/>
+          </a:xfrm>
+          <a:prstGeom prst="rect">
+            <a:avLst/>
+          </a:prstGeom>
+          <a:noFill/>
+          <a:ln/>
+        </p:spPr>
+        <p:txBody>
+          <a:bodyPr wrap="square" lIns="0" tIns="0" rIns="0" bIns="0" rtlCol="0" anchor="t"/>
+          <a:lstStyle/>
+          <a:p>
+            <a:pPr algn="ctr" indent="0" marL="0">
+              <a:buNone/>
+            </a:pPr>
+            <a:r>
+              <a:rPr lang="en-US" sz="1500" dirty="0">
+                <a:solidFill>
+                  <a:schemeClr val="tx2"/>
+                </a:solidFill>
+              </a:rPr>
+              <a:t>Lokálně stovky °C, u keramiky i přes 1 000 °C</a:t>
+            </a:r>
+            <a:endParaRPr lang="en-US" sz="1500" dirty="0"/>
+          </a:p>
+        </p:txBody>
+      </p:sp>
+      <p:pic>
+        <p:nvPicPr>
+          <p:cNvPr id="12" name="lam arrow 1" descr="šipka">    </p:cNvPr>
+          <p:cNvPicPr>
+            <a:picLocks noChangeAspect="1"/>
+          </p:cNvPicPr>
+          <p:nvPr/>
+        </p:nvPicPr>
+        <p:blipFill>
+          <a:blip r:embed="rId4"/>
+          <a:stretch>
+            <a:fillRect/>
+          </a:stretch>
+        </p:blipFill>
+        <p:spPr>
+          <a:xfrm>
+            <a:off x="7833665" y="1828800"/>
+            <a:ext cx="411480" cy="411480"/>
+          </a:xfrm>
+          <a:prstGeom prst="rect">
+            <a:avLst/>
+          </a:prstGeom>
+        </p:spPr>
+      </p:pic>
+      <p:sp>
+        <p:nvSpPr>
+          <p:cNvPr id="13" name="lam icon 2 circle"/>
+          <p:cNvSpPr/>
+          <p:nvPr/>
+        </p:nvSpPr>
+        <p:spPr>
+          <a:xfrm>
+            <a:off x="9449410" y="1463040"/>
+            <a:ext cx="1097280" cy="1097280"/>
+          </a:xfrm>
+          <a:prstGeom prst="ellipse">
+            <a:avLst/>
+          </a:prstGeom>
+          <a:solidFill>
+            <a:schemeClr val="accent1"/>
+          </a:solidFill>
+          <a:ln/>
+        </p:spPr>
+      </p:sp>
+      <p:pic>
+        <p:nvPicPr>
+          <p:cNvPr id="14" name="lam icon 2" descr="lam icon 2">    </p:cNvPr>
+          <p:cNvPicPr>
+            <a:picLocks noChangeAspect="1"/>
+          </p:cNvPicPr>
+          <p:nvPr/>
+        </p:nvPicPr>
+        <p:blipFill>
+          <a:blip r:embed="rId5"/>
+          <a:stretch>
+            <a:fillRect/>
+          </a:stretch>
+        </p:blipFill>
+        <p:spPr>
+          <a:xfrm>
+            <a:off x="9690811" y="1704442"/>
+            <a:ext cx="614477" cy="614477"/>
+          </a:xfrm>
+          <a:prstGeom prst="rect">
+            <a:avLst/>
+          </a:prstGeom>
+        </p:spPr>
+      </p:pic>
+      <p:sp>
+        <p:nvSpPr>
+          <p:cNvPr id="15" name="lam title 2"/>
+          <p:cNvSpPr txBox="1"/>
+          <p:nvPr/>
+        </p:nvSpPr>
+        <p:spPr>
+          <a:xfrm>
+            <a:off x="8352130" y="2697480"/>
+            <a:ext cx="3291840" cy="411480"/>
+          </a:xfrm>
+          <a:prstGeom prst="rect">
+            <a:avLst/>
+          </a:prstGeom>
+          <a:noFill/>
+          <a:ln/>
+        </p:spPr>
+        <p:txBody>
+          <a:bodyPr wrap="square" lIns="0" tIns="0" rIns="0" bIns="0" rtlCol="0" anchor="t"/>
+          <a:lstStyle/>
+          <a:p>
+            <a:pPr algn="ctr" indent="0" marL="0">
+              <a:buNone/>
+            </a:pPr>
+            <a:r>
+              <a:rPr lang="en-US" sz="1900" b="1" dirty="0">
+                <a:solidFill>
+                  <a:schemeClr val="tx1"/>
+                </a:solidFill>
+              </a:rPr>
+              <a:t>Nůž řeže snadno</a:t>
+            </a:r>
+            <a:endParaRPr lang="en-US" sz="1900" dirty="0"/>
+          </a:p>
+        </p:txBody>
+      </p:sp>
+      <p:sp>
+        <p:nvSpPr>
+          <p:cNvPr id="16" name="lam body 2"/>
+          <p:cNvSpPr txBox="1"/>
+          <p:nvPr/>
+        </p:nvSpPr>
+        <p:spPr>
+          <a:xfrm>
+            <a:off x="8352130" y="3108960"/>
+            <a:ext cx="3291840" cy="640080"/>
+          </a:xfrm>
+          <a:prstGeom prst="rect">
+            <a:avLst/>
+          </a:prstGeom>
+          <a:noFill/>
+          <a:ln/>
+        </p:spPr>
+        <p:txBody>
+          <a:bodyPr wrap="square" lIns="0" tIns="0" rIns="0" bIns="0" rtlCol="0" anchor="t"/>
+          <a:lstStyle/>
+          <a:p>
+            <a:pPr algn="ctr" indent="0" marL="0">
+              <a:buNone/>
+            </a:pPr>
+            <a:r>
+              <a:rPr lang="en-US" sz="1500" dirty="0">
+                <a:solidFill>
+                  <a:schemeClr val="tx2"/>
+                </a:solidFill>
+              </a:rPr>
+              <a:t>Nižší řezné síly, méně opotřebení, bez prasklin</a:t>
+            </a:r>
+            <a:endParaRPr lang="en-US" sz="1500" dirty="0"/>
+          </a:p>
+        </p:txBody>
+      </p:sp>
+      <p:sp>
+        <p:nvSpPr>
+          <p:cNvPr id="17" name="where card"/>
+          <p:cNvSpPr/>
+          <p:nvPr/>
+        </p:nvSpPr>
+        <p:spPr>
+          <a:xfrm>
+            <a:off x="548640" y="4069080"/>
+            <a:ext cx="6675120" cy="1965960"/>
+          </a:xfrm>
+          <a:prstGeom prst="roundRect">
+            <a:avLst>
+              <a:gd name="adj" fmla="val 5581"/>
+            </a:avLst>
+          </a:prstGeom>
+          <a:solidFill>
+            <a:schemeClr val="bg2"/>
+          </a:solidFill>
+          <a:ln/>
+        </p:spPr>
+      </p:sp>
+      <p:sp>
+        <p:nvSpPr>
+          <p:cNvPr id="18" name="where title"/>
+          <p:cNvSpPr txBox="1"/>
+          <p:nvPr/>
+        </p:nvSpPr>
+        <p:spPr>
+          <a:xfrm>
+            <a:off x="822960" y="4251960"/>
+            <a:ext cx="6126480" cy="411480"/>
+          </a:xfrm>
+          <a:prstGeom prst="rect">
+            <a:avLst/>
+          </a:prstGeom>
+          <a:noFill/>
+          <a:ln/>
+        </p:spPr>
+        <p:txBody>
+          <a:bodyPr wrap="square" lIns="0" tIns="0" rIns="0" bIns="0" rtlCol="0" anchor="t"/>
           <a:lstStyle/>
           <a:p>
             <a:pPr indent="0" marL="0">
               <a:buNone/>
             </a:pPr>
             <a:r>
-              <a:rPr lang="en-US" sz="2000" b="1" dirty="0">
+              <a:rPr lang="en-US" sz="1900" b="1" dirty="0">
                 <a:solidFill>
                   <a:schemeClr val="tx1"/>
                 </a:solidFill>
               </a:rPr>
-              <a:t>Nevýhody</a:t>
-            </a:r>
-            <a:endParaRPr lang="en-US" sz="2000" dirty="0"/>
-          </a:p>
-        </p:txBody>
-      </p:sp>
-      <p:sp>
-        <p:nvSpPr>
-          <p:cNvPr id="19" name="cons list"/>
-          <p:cNvSpPr txBox="1"/>
-          <p:nvPr/>
-        </p:nvSpPr>
-        <p:spPr>
-          <a:xfrm>
-            <a:off x="6217920" y="4343400"/>
-            <a:ext cx="5394960" cy="1737360"/>
+              <a:t>Kde to pomáhá</a:t>
+            </a:r>
+            <a:endParaRPr lang="en-US" sz="1900" dirty="0"/>
+          </a:p>
+        </p:txBody>
+      </p:sp>
+      <p:sp>
+        <p:nvSpPr>
+          <p:cNvPr id="19" name="where list"/>
+          <p:cNvSpPr txBox="1"/>
+          <p:nvPr/>
+        </p:nvSpPr>
+        <p:spPr>
+          <a:xfrm>
+            <a:off x="822960" y="4709160"/>
+            <a:ext cx="6126480" cy="1234440"/>
           </a:xfrm>
           <a:prstGeom prst="rect">
             <a:avLst/>
@@ -5438,7 +5892,7 @@
           <a:p>
             <a:pPr marL="228600" indent="-228600">
               <a:spcAft>
-                <a:spcPts val="800"/>
+                <a:spcPts val="400"/>
               </a:spcAft>
               <a:buSzPct val="100000"/>
               <a:buChar char="•"/>
@@ -5449,14 +5903,14 @@
                   <a:schemeClr val="tx2"/>
                 </a:solidFill>
               </a:rPr>
-              <a:t>Výroba tekutého dusíku spotřebuje hodně energie</a:t>
+              <a:t>Technická keramika (např. nitrid křemíku)</a:t>
             </a:r>
             <a:endParaRPr lang="en-US" sz="1500" dirty="0"/>
           </a:p>
           <a:p>
             <a:pPr marL="228600" indent="-228600">
               <a:spcAft>
-                <a:spcPts val="800"/>
+                <a:spcPts val="400"/>
               </a:spcAft>
               <a:buSzPct val="100000"/>
               <a:buChar char="•"/>
@@ -5467,14 +5921,14 @@
                   <a:schemeClr val="tx2"/>
                 </a:solidFill>
               </a:rPr>
-              <a:t>Drahé zařízení, izolované rozvody</a:t>
+              <a:t>Inconel a titan pro letecké motory</a:t>
             </a:r>
             <a:endParaRPr lang="en-US" sz="1500" dirty="0"/>
           </a:p>
           <a:p>
             <a:pPr marL="228600" indent="-228600">
               <a:spcAft>
-                <a:spcPts val="800"/>
+                <a:spcPts val="400"/>
               </a:spcAft>
               <a:buSzPct val="100000"/>
               <a:buChar char="•"/>
@@ -5485,9 +5939,147 @@
                   <a:schemeClr val="tx2"/>
                 </a:solidFill>
               </a:rPr>
-              <a:t>Dusík nemaže, proto se často kombinuje s mikromazáním (MQL)</a:t>
+              <a:t>Kalené oceli: delší životnost nástroje</a:t>
             </a:r>
             <a:endParaRPr lang="en-US" sz="1500" dirty="0"/>
+          </a:p>
+        </p:txBody>
+      </p:sp>
+      <p:sp>
+        <p:nvSpPr>
+          <p:cNvPr id="20" name="contrast card"/>
+          <p:cNvSpPr/>
+          <p:nvPr/>
+        </p:nvSpPr>
+        <p:spPr>
+          <a:xfrm>
+            <a:off x="7589520" y="4069080"/>
+            <a:ext cx="4023360" cy="1965960"/>
+          </a:xfrm>
+          <a:prstGeom prst="roundRect">
+            <a:avLst>
+              <a:gd name="adj" fmla="val 5581"/>
+            </a:avLst>
+          </a:prstGeom>
+          <a:solidFill>
+            <a:schemeClr val="tx1"/>
+          </a:solidFill>
+          <a:ln/>
+        </p:spPr>
+      </p:sp>
+      <p:sp>
+        <p:nvSpPr>
+          <p:cNvPr id="21" name="contrast icon circle"/>
+          <p:cNvSpPr/>
+          <p:nvPr/>
+        </p:nvSpPr>
+        <p:spPr>
+          <a:xfrm>
+            <a:off x="7863840" y="4251960"/>
+            <a:ext cx="548640" cy="548640"/>
+          </a:xfrm>
+          <a:prstGeom prst="ellipse">
+            <a:avLst/>
+          </a:prstGeom>
+          <a:solidFill>
+            <a:schemeClr val="accent2"/>
+          </a:solidFill>
+          <a:ln/>
+        </p:spPr>
+      </p:sp>
+      <p:pic>
+        <p:nvPicPr>
+          <p:cNvPr id="22" name="contrast icon" descr="contrast icon">    </p:cNvPr>
+          <p:cNvPicPr>
+            <a:picLocks noChangeAspect="1"/>
+          </p:cNvPicPr>
+          <p:nvPr/>
+        </p:nvPicPr>
+        <p:blipFill>
+          <a:blip r:embed="rId6"/>
+          <a:stretch>
+            <a:fillRect/>
+          </a:stretch>
+        </p:blipFill>
+        <p:spPr>
+          <a:xfrm>
+            <a:off x="7984541" y="4372661"/>
+            <a:ext cx="307238" cy="307238"/>
+          </a:xfrm>
+          <a:prstGeom prst="rect">
+            <a:avLst/>
+          </a:prstGeom>
+        </p:spPr>
+      </p:pic>
+      <p:sp>
+        <p:nvSpPr>
+          <p:cNvPr id="23" name="contrast title"/>
+          <p:cNvSpPr txBox="1"/>
+          <p:nvPr/>
+        </p:nvSpPr>
+        <p:spPr>
+          <a:xfrm>
+            <a:off x="8549640" y="4251960"/>
+            <a:ext cx="2926080" cy="548640"/>
+          </a:xfrm>
+          <a:prstGeom prst="rect">
+            <a:avLst/>
+          </a:prstGeom>
+          <a:noFill/>
+          <a:ln/>
+        </p:spPr>
+        <p:txBody>
+          <a:bodyPr wrap="square" lIns="0" tIns="0" rIns="0" bIns="0" rtlCol="0" anchor="ctr"/>
+          <a:lstStyle/>
+          <a:p>
+            <a:pPr indent="0" marL="0">
+              <a:buNone/>
+            </a:pPr>
+            <a:r>
+              <a:rPr lang="en-US" sz="1800" b="1" dirty="0">
+                <a:solidFill>
+                  <a:schemeClr val="bg1"/>
+                </a:solidFill>
+              </a:rPr>
+              <a:t>Opak kryogenu</a:t>
+            </a:r>
+            <a:endParaRPr lang="en-US" sz="1800" dirty="0"/>
+          </a:p>
+        </p:txBody>
+      </p:sp>
+      <p:sp>
+        <p:nvSpPr>
+          <p:cNvPr id="24" name="contrast text"/>
+          <p:cNvSpPr txBox="1"/>
+          <p:nvPr/>
+        </p:nvSpPr>
+        <p:spPr>
+          <a:xfrm>
+            <a:off x="7863840" y="4937760"/>
+            <a:ext cx="3520440" cy="1005840"/>
+          </a:xfrm>
+          <a:prstGeom prst="rect">
+            <a:avLst/>
+          </a:prstGeom>
+          <a:noFill/>
+          <a:ln/>
+        </p:spPr>
+        <p:txBody>
+          <a:bodyPr wrap="square" lIns="0" tIns="0" rIns="0" bIns="0" rtlCol="0" anchor="t"/>
+          <a:lstStyle/>
+          <a:p>
+            <a:pPr indent="0" marL="0">
+              <a:buNone/>
+            </a:pPr>
+            <a:r>
+              <a:rPr lang="en-US" sz="1400" dirty="0">
+                <a:solidFill>
+                  <a:schemeClr val="bg1"/>
+                </a:solidFill>
+              </a:rPr>
+              <a:t>Kryogenní obrábění chladí nástroj, laser naopak ohřívá obrobek. Obojí bojuje s tvrdostí a teplem.</a:t>
+            </a:r>
+            <a:endParaRPr lang="en-US" sz="1400" dirty="0"/>
           </a:p>
         </p:txBody>
       </p:sp>
@@ -5593,7 +6185,7 @@
                   <a:schemeClr val="tx1"/>
                 </a:solidFill>
               </a:rPr>
-              <a:t>3 · Chytré nástroje a umělá inteligence</a:t>
+              <a:t>4 · Chytré nástroje a umělá inteligence</a:t>
             </a:r>
             <a:endParaRPr lang="en-US" sz="3400" dirty="0"/>
           </a:p>
@@ -6215,7 +6807,7 @@
                   <a:schemeClr val="tx1"/>
                 </a:solidFill>
               </a:rPr>
-              <a:t>4 · Ultrazvukem asistované soustružení</a:t>
+              <a:t>5 · Ultrazvukem asistované soustružení</a:t>
             </a:r>
             <a:endParaRPr lang="en-US" sz="3400" dirty="0"/>
           </a:p>
@@ -7177,7 +7769,7 @@
                   <a:schemeClr val="tx1"/>
                 </a:solidFill>
               </a:rPr>
-              <a:t>5 · Diamantové soustružení na nanometry</a:t>
+              <a:t>6 · Diamantové soustružení na nanometry</a:t>
             </a:r>
             <a:endParaRPr lang="en-US" sz="3400" dirty="0"/>
           </a:p>

</xml_diff>